<commit_message>
Cutover deck: recurrent running cost, from the Production Readiness report
Slide 9 of OEGroup_Board_Production_Readiness.pptx (3 Sept) rebuilt as
slide 9 of the cutover deck, with the monthly figures unchanged and three
updates: the annual figure is corrected (₦516,375 x 12 = ₦6.20M, not the
₦6.10M printed), the gateway note names Flutterwave rather than Paystack,
and SMS-out, Gemini free tier and PITR declined-on-cost are stated.

Co-Authored-By: Claude Opus 5.5 <noreply@anthropic.com>
</commit_message>
<xml_diff>
--- a/docs/OE_Group_Production_Cutover.pptx
+++ b/docs/OE_Group_Production_Cutover.pptx
@@ -15,6 +15,7 @@
     <p:sldId id="263" r:id="rId15"/>
     <p:sldId id="264" r:id="rId16"/>
     <p:sldId id="265" r:id="rId17"/>
+    <p:sldId id="266" r:id="rId18"/>
   </p:sldIdLst>
   <p:sldSz cx="12192000" cy="6858000" type="screen4x3"/>
   <p:notesSz cx="6858000" cy="9144000"/>
@@ -810,6 +811,76 @@
           <a:lstStyle/>
           <a:p>
             <a:r>
+              <a:t>GO_LIVE_BUILD_PLAN Stage 1: 1.1 (13 DPAs + Cloudflare as fourteenth; correction note to counsel 28 Sept; self-serve DPAs being accepted; Telegram carries live conversations with no DPA), 1.2, 1.5, 1.8, 1.9, 1.10, 1.6, 1.11/6.2, 1.12/6.4. 1.4 (data-subject-rights procedure) is written, not yet published, and rides on 1.2 and 1.5.</a:t>
+            </a:r>
+          </a:p>
+        </p:txBody>
+      </p:sp>
+      <p:sp>
+        <p:nvSpPr>
+          <p:cNvPr id="4" name="Slide Number Placeholder 3"/>
+          <p:cNvSpPr>
+            <a:spLocks noGrp="1"/>
+          </p:cNvSpPr>
+          <p:nvPr>
+            <p:ph type="sldNum" idx="5" sz="quarter"/>
+          </p:nvPr>
+        </p:nvSpPr>
+        <p:spPr/>
+      </p:sp>
+    </p:spTree>
+  </p:cSld>
+  <p:clrMapOvr>
+    <a:masterClrMapping/>
+  </p:clrMapOvr>
+</p:notes>
+</file>
+
+<file path=ppt/notesSlides/notesSlide11.xml><?xml version="1.0" encoding="utf-8"?>
+<p:notes xmlns:a="http://schemas.openxmlformats.org/drawingml/2006/main" xmlns:p="http://schemas.openxmlformats.org/presentationml/2006/main" xmlns:r="http://schemas.openxmlformats.org/officeDocument/2006/relationships">
+  <p:cSld>
+    <p:spTree>
+      <p:nvGrpSpPr>
+        <p:cNvPr id="1" name=""/>
+        <p:cNvGrpSpPr/>
+        <p:nvPr/>
+      </p:nvGrpSpPr>
+      <p:grpSpPr>
+        <a:xfrm>
+          <a:off x="0" y="0"/>
+          <a:ext cx="0" cy="0"/>
+          <a:chOff x="0" y="0"/>
+          <a:chExt cx="0" cy="0"/>
+        </a:xfrm>
+      </p:grpSpPr>
+      <p:sp>
+        <p:nvSpPr>
+          <p:cNvPr id="2" name="Slide Image Placeholder 1"/>
+          <p:cNvSpPr>
+            <a:spLocks noGrp="1"/>
+          </p:cNvSpPr>
+          <p:nvPr>
+            <p:ph type="sldImg" idx="2"/>
+          </p:nvPr>
+        </p:nvSpPr>
+        <p:spPr/>
+      </p:sp>
+      <p:sp>
+        <p:nvSpPr>
+          <p:cNvPr id="3" name="Notes Placeholder 2"/>
+          <p:cNvSpPr>
+            <a:spLocks noGrp="1"/>
+          </p:cNvSpPr>
+          <p:nvPr>
+            <p:ph type="body" idx="3" sz="quarter"/>
+          </p:nvPr>
+        </p:nvSpPr>
+        <p:spPr/>
+        <p:txBody>
+          <a:bodyPr/>
+          <a:lstStyle/>
+          <a:p>
+            <a:r>
               <a:t>Close on the five decisions. rc9 (Next.js 15, tag v1.0.0-rc9 at 9dab9a2, 132/132 on staging) went live 29 Sept 09:07; freeze ruleset restored 09:08. Context: the 23 Sept edition asked for two uninterrupted days; the cutover itself is now done. What remains is compliance and the live gateway key, both board-owned.</a:t>
             </a:r>
           </a:p>
@@ -1370,7 +1441,7 @@
           <a:lstStyle/>
           <a:p>
             <a:r>
-              <a:t>GO_LIVE_BUILD_PLAN Stage 1: 1.1 (13 DPAs + Cloudflare as fourteenth; correction note to counsel 28 Sept; self-serve DPAs being accepted; Telegram carries live conversations with no DPA), 1.2, 1.5, 1.8, 1.9, 1.10, 1.6, 1.11/6.2, 1.12/6.4. 1.4 (data-subject-rights procedure) is written, not yet published, and rides on 1.2 and 1.5.</a:t>
+              <a:t>Source: slide 9 of OEGroup_Board_Production_Readiness.pptx (Google Drive, 3 Sept 2026). Monthly figures are carried over unchanged; they are the report's estimates, not re-quoted. Corrections and updates: (1) the report printed ₦6.10M a year; ₦516,375 x 12 = ₦6,196,500, so ≈ ₦6.20M; the lean ₦408K x 12 ≈ ₦4.90M. (2) The gateway note quoted Paystack fees; Paystack was superseded by Flutterwave on 23 Sept (build plan 2.12), and Flutterwave rates should be taken from its signed agreement. (3) SMS fallback is OUT (2.8, 20 Sept) and Gemini billing is not enabled (2.7), so the configuration live today is closer to the lean figure; the Channels row still includes SMS as costed. (4) Cloudflare is now also the sign-in CAPTCHA (Turnstile, 2.8). (5) PITR was re-declined on cost at go-live, 28 Sept (2.5: $100/month per project).</a:t>
             </a:r>
           </a:p>
         </p:txBody>
@@ -4696,6 +4767,1991 @@
     <p:bg>
       <p:bgPr>
         <a:solidFill>
+          <a:srgbClr val="F4F7FB"/>
+        </a:solidFill>
+        <a:effectLst/>
+      </p:bgPr>
+    </p:bg>
+    <p:spTree>
+      <p:nvGrpSpPr>
+        <p:cNvPr id="1" name=""/>
+        <p:cNvGrpSpPr/>
+        <p:nvPr/>
+      </p:nvGrpSpPr>
+      <p:grpSpPr/>
+      <p:sp>
+        <p:nvSpPr>
+          <p:cNvPr id="2" name="TextBox 1"/>
+          <p:cNvSpPr txBox="1"/>
+          <p:nvPr/>
+        </p:nvSpPr>
+        <p:spPr>
+          <a:xfrm>
+            <a:off x="548640" y="411480"/>
+            <a:ext cx="11064240" cy="685800"/>
+          </a:xfrm>
+          <a:prstGeom prst="rect">
+            <a:avLst/>
+          </a:prstGeom>
+          <a:noFill/>
+        </p:spPr>
+        <p:txBody>
+          <a:bodyPr wrap="square" lIns="0" rIns="0" tIns="0" bIns="0" anchor="t">
+            <a:spAutoFit/>
+          </a:bodyPr>
+          <a:lstStyle/>
+          <a:p>
+            <a:pPr algn="l"/>
+            <a:r>
+              <a:rPr sz="3200" b="1" i="0">
+                <a:solidFill>
+                  <a:srgbClr val="003366"/>
+                </a:solidFill>
+                <a:latin typeface="Cambria"/>
+              </a:rPr>
+              <a:t>The board's items — what is done and what is still open</a:t>
+            </a:r>
+          </a:p>
+        </p:txBody>
+      </p:sp>
+      <p:sp>
+        <p:nvSpPr>
+          <p:cNvPr id="3" name="TextBox 2"/>
+          <p:cNvSpPr txBox="1"/>
+          <p:nvPr/>
+        </p:nvSpPr>
+        <p:spPr>
+          <a:xfrm>
+            <a:off x="548640" y="1097280"/>
+            <a:ext cx="11064240" cy="365760"/>
+          </a:xfrm>
+          <a:prstGeom prst="rect">
+            <a:avLst/>
+          </a:prstGeom>
+          <a:noFill/>
+        </p:spPr>
+        <p:txBody>
+          <a:bodyPr wrap="square" lIns="0" rIns="0" tIns="0" bIns="0" anchor="t">
+            <a:spAutoFit/>
+          </a:bodyPr>
+          <a:lstStyle/>
+          <a:p>
+            <a:pPr algn="l"/>
+            <a:r>
+              <a:rPr sz="1400" b="0" i="0">
+                <a:solidFill>
+                  <a:srgbClr val="7A8A9B"/>
+                </a:solidFill>
+                <a:latin typeface="Calibri"/>
+              </a:rPr>
+              <a:t>Go-live was authorised with the open items below as a deliberate decision. Each still needs an owner and a date.</a:t>
+            </a:r>
+          </a:p>
+        </p:txBody>
+      </p:sp>
+      <p:sp>
+        <p:nvSpPr>
+          <p:cNvPr id="4" name="Rounded Rectangle 3"/>
+          <p:cNvSpPr/>
+          <p:nvPr/>
+        </p:nvSpPr>
+        <p:spPr>
+          <a:xfrm>
+            <a:off x="548640" y="1783080"/>
+            <a:ext cx="3566160" cy="1280160"/>
+          </a:xfrm>
+          <a:prstGeom prst="roundRect">
+            <a:avLst>
+              <a:gd name="adj" fmla="val 6000"/>
+            </a:avLst>
+          </a:prstGeom>
+          <a:solidFill>
+            <a:srgbClr val="FFFFFF"/>
+          </a:solidFill>
+          <a:ln w="9525">
+            <a:solidFill>
+              <a:srgbClr val="D8E0EA"/>
+            </a:solidFill>
+          </a:ln>
+          <a:effectLst/>
+        </p:spPr>
+        <p:style>
+          <a:lnRef idx="1">
+            <a:schemeClr val="accent1"/>
+          </a:lnRef>
+          <a:fillRef idx="3">
+            <a:schemeClr val="accent1"/>
+          </a:fillRef>
+          <a:effectRef idx="2">
+            <a:schemeClr val="accent1"/>
+          </a:effectRef>
+          <a:fontRef idx="minor">
+            <a:schemeClr val="lt1"/>
+          </a:fontRef>
+        </p:style>
+        <p:txBody>
+          <a:bodyPr rtlCol="0" anchor="ctr"/>
+          <a:lstStyle/>
+          <a:p/>
+        </p:txBody>
+      </p:sp>
+      <p:sp>
+        <p:nvSpPr>
+          <p:cNvPr id="5" name="TextBox 4"/>
+          <p:cNvSpPr txBox="1"/>
+          <p:nvPr/>
+        </p:nvSpPr>
+        <p:spPr>
+          <a:xfrm>
+            <a:off x="777240" y="1947672"/>
+            <a:ext cx="2240280" cy="548640"/>
+          </a:xfrm>
+          <a:prstGeom prst="rect">
+            <a:avLst/>
+          </a:prstGeom>
+          <a:noFill/>
+        </p:spPr>
+        <p:txBody>
+          <a:bodyPr wrap="square" lIns="0" rIns="0" tIns="0" bIns="0" anchor="t">
+            <a:spAutoFit/>
+          </a:bodyPr>
+          <a:lstStyle/>
+          <a:p>
+            <a:pPr algn="l"/>
+            <a:r>
+              <a:rPr sz="1300" b="1" i="0">
+                <a:solidFill>
+                  <a:srgbClr val="003366"/>
+                </a:solidFill>
+                <a:latin typeface="Calibri"/>
+              </a:rPr>
+              <a:t>Processor agreements (14)</a:t>
+            </a:r>
+          </a:p>
+        </p:txBody>
+      </p:sp>
+      <p:sp>
+        <p:nvSpPr>
+          <p:cNvPr id="6" name="Rounded Rectangle 5"/>
+          <p:cNvSpPr/>
+          <p:nvPr/>
+        </p:nvSpPr>
+        <p:spPr>
+          <a:xfrm>
+            <a:off x="3154680" y="1965960"/>
+            <a:ext cx="777240" cy="256032"/>
+          </a:xfrm>
+          <a:prstGeom prst="roundRect">
+            <a:avLst>
+              <a:gd name="adj" fmla="val 50000"/>
+            </a:avLst>
+          </a:prstGeom>
+          <a:solidFill>
+            <a:srgbClr val="B23A2E"/>
+          </a:solidFill>
+          <a:ln>
+            <a:noFill/>
+          </a:ln>
+          <a:effectLst/>
+        </p:spPr>
+        <p:style>
+          <a:lnRef idx="1">
+            <a:schemeClr val="accent1"/>
+          </a:lnRef>
+          <a:fillRef idx="3">
+            <a:schemeClr val="accent1"/>
+          </a:fillRef>
+          <a:effectRef idx="2">
+            <a:schemeClr val="accent1"/>
+          </a:effectRef>
+          <a:fontRef idx="minor">
+            <a:schemeClr val="lt1"/>
+          </a:fontRef>
+        </p:style>
+        <p:txBody>
+          <a:bodyPr rtlCol="0" anchor="ctr" lIns="0" rIns="0" tIns="0" bIns="0"/>
+          <a:lstStyle/>
+          <a:p>
+            <a:pPr algn="ctr"/>
+            <a:r>
+              <a:rPr sz="800" b="1">
+                <a:solidFill>
+                  <a:srgbClr val="FFFFFF"/>
+                </a:solidFill>
+                <a:latin typeface="Calibri"/>
+              </a:rPr>
+              <a:t>OPEN</a:t>
+            </a:r>
+          </a:p>
+        </p:txBody>
+      </p:sp>
+      <p:sp>
+        <p:nvSpPr>
+          <p:cNvPr id="7" name="TextBox 6"/>
+          <p:cNvSpPr txBox="1"/>
+          <p:nvPr/>
+        </p:nvSpPr>
+        <p:spPr>
+          <a:xfrm>
+            <a:off x="777240" y="2560320"/>
+            <a:ext cx="3108960" cy="228600"/>
+          </a:xfrm>
+          <a:prstGeom prst="rect">
+            <a:avLst/>
+          </a:prstGeom>
+          <a:noFill/>
+        </p:spPr>
+        <p:txBody>
+          <a:bodyPr wrap="square" lIns="0" rIns="0" tIns="0" bIns="0" anchor="t">
+            <a:spAutoFit/>
+          </a:bodyPr>
+          <a:lstStyle/>
+          <a:p>
+            <a:pPr algn="l"/>
+            <a:r>
+              <a:rPr sz="850" b="1" i="0" spc="80">
+                <a:solidFill>
+                  <a:srgbClr val="7A8A9B"/>
+                </a:solidFill>
+                <a:latin typeface="Calibri"/>
+              </a:rPr>
+              <a:t>LEGAL + DPO</a:t>
+            </a:r>
+          </a:p>
+        </p:txBody>
+      </p:sp>
+      <p:sp>
+        <p:nvSpPr>
+          <p:cNvPr id="8" name="TextBox 7"/>
+          <p:cNvSpPr txBox="1"/>
+          <p:nvPr/>
+        </p:nvSpPr>
+        <p:spPr>
+          <a:xfrm>
+            <a:off x="777240" y="2761488"/>
+            <a:ext cx="3108960" cy="274320"/>
+          </a:xfrm>
+          <a:prstGeom prst="rect">
+            <a:avLst/>
+          </a:prstGeom>
+          <a:noFill/>
+        </p:spPr>
+        <p:txBody>
+          <a:bodyPr wrap="square" lIns="0" rIns="0" tIns="0" bIns="0" anchor="t">
+            <a:spAutoFit/>
+          </a:bodyPr>
+          <a:lstStyle/>
+          <a:p>
+            <a:pPr algn="l"/>
+            <a:r>
+              <a:rPr sz="1100" b="0" i="0">
+                <a:solidFill>
+                  <a:srgbClr val="1C2B3A"/>
+                </a:solidFill>
+                <a:latin typeface="Calibri"/>
+              </a:rPr>
+              <a:t>Pack with counsel; none signed yet</a:t>
+            </a:r>
+          </a:p>
+        </p:txBody>
+      </p:sp>
+      <p:sp>
+        <p:nvSpPr>
+          <p:cNvPr id="9" name="Rounded Rectangle 8"/>
+          <p:cNvSpPr/>
+          <p:nvPr/>
+        </p:nvSpPr>
+        <p:spPr>
+          <a:xfrm>
+            <a:off x="4297679" y="1783080"/>
+            <a:ext cx="3566160" cy="1280160"/>
+          </a:xfrm>
+          <a:prstGeom prst="roundRect">
+            <a:avLst>
+              <a:gd name="adj" fmla="val 6000"/>
+            </a:avLst>
+          </a:prstGeom>
+          <a:solidFill>
+            <a:srgbClr val="FFFFFF"/>
+          </a:solidFill>
+          <a:ln w="9525">
+            <a:solidFill>
+              <a:srgbClr val="D8E0EA"/>
+            </a:solidFill>
+          </a:ln>
+          <a:effectLst/>
+        </p:spPr>
+        <p:style>
+          <a:lnRef idx="1">
+            <a:schemeClr val="accent1"/>
+          </a:lnRef>
+          <a:fillRef idx="3">
+            <a:schemeClr val="accent1"/>
+          </a:fillRef>
+          <a:effectRef idx="2">
+            <a:schemeClr val="accent1"/>
+          </a:effectRef>
+          <a:fontRef idx="minor">
+            <a:schemeClr val="lt1"/>
+          </a:fontRef>
+        </p:style>
+        <p:txBody>
+          <a:bodyPr rtlCol="0" anchor="ctr"/>
+          <a:lstStyle/>
+          <a:p/>
+        </p:txBody>
+      </p:sp>
+      <p:sp>
+        <p:nvSpPr>
+          <p:cNvPr id="10" name="TextBox 9"/>
+          <p:cNvSpPr txBox="1"/>
+          <p:nvPr/>
+        </p:nvSpPr>
+        <p:spPr>
+          <a:xfrm>
+            <a:off x="4526279" y="1947672"/>
+            <a:ext cx="2240280" cy="548640"/>
+          </a:xfrm>
+          <a:prstGeom prst="rect">
+            <a:avLst/>
+          </a:prstGeom>
+          <a:noFill/>
+        </p:spPr>
+        <p:txBody>
+          <a:bodyPr wrap="square" lIns="0" rIns="0" tIns="0" bIns="0" anchor="t">
+            <a:spAutoFit/>
+          </a:bodyPr>
+          <a:lstStyle/>
+          <a:p>
+            <a:pPr algn="l"/>
+            <a:r>
+              <a:rPr sz="1300" b="1" i="0">
+                <a:solidFill>
+                  <a:srgbClr val="003366"/>
+                </a:solidFill>
+                <a:latin typeface="Calibri"/>
+              </a:rPr>
+              <a:t>Privacy notice</a:t>
+            </a:r>
+          </a:p>
+        </p:txBody>
+      </p:sp>
+      <p:sp>
+        <p:nvSpPr>
+          <p:cNvPr id="11" name="Rounded Rectangle 10"/>
+          <p:cNvSpPr/>
+          <p:nvPr/>
+        </p:nvSpPr>
+        <p:spPr>
+          <a:xfrm>
+            <a:off x="6903720" y="1965960"/>
+            <a:ext cx="777240" cy="256032"/>
+          </a:xfrm>
+          <a:prstGeom prst="roundRect">
+            <a:avLst>
+              <a:gd name="adj" fmla="val 50000"/>
+            </a:avLst>
+          </a:prstGeom>
+          <a:solidFill>
+            <a:srgbClr val="B5680A"/>
+          </a:solidFill>
+          <a:ln>
+            <a:noFill/>
+          </a:ln>
+          <a:effectLst/>
+        </p:spPr>
+        <p:style>
+          <a:lnRef idx="1">
+            <a:schemeClr val="accent1"/>
+          </a:lnRef>
+          <a:fillRef idx="3">
+            <a:schemeClr val="accent1"/>
+          </a:fillRef>
+          <a:effectRef idx="2">
+            <a:schemeClr val="accent1"/>
+          </a:effectRef>
+          <a:fontRef idx="minor">
+            <a:schemeClr val="lt1"/>
+          </a:fontRef>
+        </p:style>
+        <p:txBody>
+          <a:bodyPr rtlCol="0" anchor="ctr" lIns="0" rIns="0" tIns="0" bIns="0"/>
+          <a:lstStyle/>
+          <a:p>
+            <a:pPr algn="ctr"/>
+            <a:r>
+              <a:rPr sz="800" b="1">
+                <a:solidFill>
+                  <a:srgbClr val="FFFFFF"/>
+                </a:solidFill>
+                <a:latin typeface="Calibri"/>
+              </a:rPr>
+              <a:t>PART</a:t>
+            </a:r>
+          </a:p>
+        </p:txBody>
+      </p:sp>
+      <p:sp>
+        <p:nvSpPr>
+          <p:cNvPr id="12" name="TextBox 11"/>
+          <p:cNvSpPr txBox="1"/>
+          <p:nvPr/>
+        </p:nvSpPr>
+        <p:spPr>
+          <a:xfrm>
+            <a:off x="4526279" y="2560320"/>
+            <a:ext cx="3108960" cy="228600"/>
+          </a:xfrm>
+          <a:prstGeom prst="rect">
+            <a:avLst/>
+          </a:prstGeom>
+          <a:noFill/>
+        </p:spPr>
+        <p:txBody>
+          <a:bodyPr wrap="square" lIns="0" rIns="0" tIns="0" bIns="0" anchor="t">
+            <a:spAutoFit/>
+          </a:bodyPr>
+          <a:lstStyle/>
+          <a:p>
+            <a:pPr algn="l"/>
+            <a:r>
+              <a:rPr sz="850" b="1" i="0" spc="80">
+                <a:solidFill>
+                  <a:srgbClr val="7A8A9B"/>
+                </a:solidFill>
+                <a:latin typeface="Calibri"/>
+              </a:rPr>
+              <a:t>LEGAL</a:t>
+            </a:r>
+          </a:p>
+        </p:txBody>
+      </p:sp>
+      <p:sp>
+        <p:nvSpPr>
+          <p:cNvPr id="13" name="TextBox 12"/>
+          <p:cNvSpPr txBox="1"/>
+          <p:nvPr/>
+        </p:nvSpPr>
+        <p:spPr>
+          <a:xfrm>
+            <a:off x="4526279" y="2761488"/>
+            <a:ext cx="3108960" cy="274320"/>
+          </a:xfrm>
+          <a:prstGeom prst="rect">
+            <a:avLst/>
+          </a:prstGeom>
+          <a:noFill/>
+        </p:spPr>
+        <p:txBody>
+          <a:bodyPr wrap="square" lIns="0" rIns="0" tIns="0" bIns="0" anchor="t">
+            <a:spAutoFit/>
+          </a:bodyPr>
+          <a:lstStyle/>
+          <a:p>
+            <a:pPr algn="l"/>
+            <a:r>
+              <a:rPr sz="1100" b="0" i="0">
+                <a:solidFill>
+                  <a:srgbClr val="1C2B3A"/>
+                </a:solidFill>
+                <a:latin typeface="Calibri"/>
+              </a:rPr>
+              <a:t>Published 24 Sept; legal review owed</a:t>
+            </a:r>
+          </a:p>
+        </p:txBody>
+      </p:sp>
+      <p:sp>
+        <p:nvSpPr>
+          <p:cNvPr id="14" name="Rounded Rectangle 13"/>
+          <p:cNvSpPr/>
+          <p:nvPr/>
+        </p:nvSpPr>
+        <p:spPr>
+          <a:xfrm>
+            <a:off x="8046719" y="1783080"/>
+            <a:ext cx="3566160" cy="1280160"/>
+          </a:xfrm>
+          <a:prstGeom prst="roundRect">
+            <a:avLst>
+              <a:gd name="adj" fmla="val 6000"/>
+            </a:avLst>
+          </a:prstGeom>
+          <a:solidFill>
+            <a:srgbClr val="FFFFFF"/>
+          </a:solidFill>
+          <a:ln w="9525">
+            <a:solidFill>
+              <a:srgbClr val="D8E0EA"/>
+            </a:solidFill>
+          </a:ln>
+          <a:effectLst/>
+        </p:spPr>
+        <p:style>
+          <a:lnRef idx="1">
+            <a:schemeClr val="accent1"/>
+          </a:lnRef>
+          <a:fillRef idx="3">
+            <a:schemeClr val="accent1"/>
+          </a:fillRef>
+          <a:effectRef idx="2">
+            <a:schemeClr val="accent1"/>
+          </a:effectRef>
+          <a:fontRef idx="minor">
+            <a:schemeClr val="lt1"/>
+          </a:fontRef>
+        </p:style>
+        <p:txBody>
+          <a:bodyPr rtlCol="0" anchor="ctr"/>
+          <a:lstStyle/>
+          <a:p/>
+        </p:txBody>
+      </p:sp>
+      <p:sp>
+        <p:nvSpPr>
+          <p:cNvPr id="15" name="TextBox 14"/>
+          <p:cNvSpPr txBox="1"/>
+          <p:nvPr/>
+        </p:nvSpPr>
+        <p:spPr>
+          <a:xfrm>
+            <a:off x="8275319" y="1947672"/>
+            <a:ext cx="2240280" cy="548640"/>
+          </a:xfrm>
+          <a:prstGeom prst="rect">
+            <a:avLst/>
+          </a:prstGeom>
+          <a:noFill/>
+        </p:spPr>
+        <p:txBody>
+          <a:bodyPr wrap="square" lIns="0" rIns="0" tIns="0" bIns="0" anchor="t">
+            <a:spAutoFit/>
+          </a:bodyPr>
+          <a:lstStyle/>
+          <a:p>
+            <a:pPr algn="l"/>
+            <a:r>
+              <a:rPr sz="1300" b="1" i="0">
+                <a:solidFill>
+                  <a:srgbClr val="003366"/>
+                </a:solidFill>
+                <a:latin typeface="Calibri"/>
+              </a:rPr>
+              <a:t>NDPC registration; DPO published</a:t>
+            </a:r>
+          </a:p>
+        </p:txBody>
+      </p:sp>
+      <p:sp>
+        <p:nvSpPr>
+          <p:cNvPr id="16" name="Rounded Rectangle 15"/>
+          <p:cNvSpPr/>
+          <p:nvPr/>
+        </p:nvSpPr>
+        <p:spPr>
+          <a:xfrm>
+            <a:off x="10652759" y="1965960"/>
+            <a:ext cx="777240" cy="256032"/>
+          </a:xfrm>
+          <a:prstGeom prst="roundRect">
+            <a:avLst>
+              <a:gd name="adj" fmla="val 50000"/>
+            </a:avLst>
+          </a:prstGeom>
+          <a:solidFill>
+            <a:srgbClr val="B23A2E"/>
+          </a:solidFill>
+          <a:ln>
+            <a:noFill/>
+          </a:ln>
+          <a:effectLst/>
+        </p:spPr>
+        <p:style>
+          <a:lnRef idx="1">
+            <a:schemeClr val="accent1"/>
+          </a:lnRef>
+          <a:fillRef idx="3">
+            <a:schemeClr val="accent1"/>
+          </a:fillRef>
+          <a:effectRef idx="2">
+            <a:schemeClr val="accent1"/>
+          </a:effectRef>
+          <a:fontRef idx="minor">
+            <a:schemeClr val="lt1"/>
+          </a:fontRef>
+        </p:style>
+        <p:txBody>
+          <a:bodyPr rtlCol="0" anchor="ctr" lIns="0" rIns="0" tIns="0" bIns="0"/>
+          <a:lstStyle/>
+          <a:p>
+            <a:pPr algn="ctr"/>
+            <a:r>
+              <a:rPr sz="800" b="1">
+                <a:solidFill>
+                  <a:srgbClr val="FFFFFF"/>
+                </a:solidFill>
+                <a:latin typeface="Calibri"/>
+              </a:rPr>
+              <a:t>OPEN</a:t>
+            </a:r>
+          </a:p>
+        </p:txBody>
+      </p:sp>
+      <p:sp>
+        <p:nvSpPr>
+          <p:cNvPr id="17" name="TextBox 16"/>
+          <p:cNvSpPr txBox="1"/>
+          <p:nvPr/>
+        </p:nvSpPr>
+        <p:spPr>
+          <a:xfrm>
+            <a:off x="8275319" y="2560320"/>
+            <a:ext cx="3108960" cy="228600"/>
+          </a:xfrm>
+          <a:prstGeom prst="rect">
+            <a:avLst/>
+          </a:prstGeom>
+          <a:noFill/>
+        </p:spPr>
+        <p:txBody>
+          <a:bodyPr wrap="square" lIns="0" rIns="0" tIns="0" bIns="0" anchor="t">
+            <a:spAutoFit/>
+          </a:bodyPr>
+          <a:lstStyle/>
+          <a:p>
+            <a:pPr algn="l"/>
+            <a:r>
+              <a:rPr sz="850" b="1" i="0" spc="80">
+                <a:solidFill>
+                  <a:srgbClr val="7A8A9B"/>
+                </a:solidFill>
+                <a:latin typeface="Calibri"/>
+              </a:rPr>
+              <a:t>LEGAL</a:t>
+            </a:r>
+          </a:p>
+        </p:txBody>
+      </p:sp>
+      <p:sp>
+        <p:nvSpPr>
+          <p:cNvPr id="18" name="TextBox 17"/>
+          <p:cNvSpPr txBox="1"/>
+          <p:nvPr/>
+        </p:nvSpPr>
+        <p:spPr>
+          <a:xfrm>
+            <a:off x="8275319" y="2761488"/>
+            <a:ext cx="3108960" cy="274320"/>
+          </a:xfrm>
+          <a:prstGeom prst="rect">
+            <a:avLst/>
+          </a:prstGeom>
+          <a:noFill/>
+        </p:spPr>
+        <p:txBody>
+          <a:bodyPr wrap="square" lIns="0" rIns="0" tIns="0" bIns="0" anchor="t">
+            <a:spAutoFit/>
+          </a:bodyPr>
+          <a:lstStyle/>
+          <a:p>
+            <a:pPr algn="l"/>
+            <a:r>
+              <a:rPr sz="1100" b="0" i="0">
+                <a:solidFill>
+                  <a:srgbClr val="1C2B3A"/>
+                </a:solidFill>
+                <a:latin typeface="Calibri"/>
+              </a:rPr>
+              <a:t>Not started</a:t>
+            </a:r>
+          </a:p>
+        </p:txBody>
+      </p:sp>
+      <p:sp>
+        <p:nvSpPr>
+          <p:cNvPr id="19" name="Rounded Rectangle 18"/>
+          <p:cNvSpPr/>
+          <p:nvPr/>
+        </p:nvSpPr>
+        <p:spPr>
+          <a:xfrm>
+            <a:off x="548640" y="3246120"/>
+            <a:ext cx="3566160" cy="1280160"/>
+          </a:xfrm>
+          <a:prstGeom prst="roundRect">
+            <a:avLst>
+              <a:gd name="adj" fmla="val 6000"/>
+            </a:avLst>
+          </a:prstGeom>
+          <a:solidFill>
+            <a:srgbClr val="FFFFFF"/>
+          </a:solidFill>
+          <a:ln w="9525">
+            <a:solidFill>
+              <a:srgbClr val="D8E0EA"/>
+            </a:solidFill>
+          </a:ln>
+          <a:effectLst/>
+        </p:spPr>
+        <p:style>
+          <a:lnRef idx="1">
+            <a:schemeClr val="accent1"/>
+          </a:lnRef>
+          <a:fillRef idx="3">
+            <a:schemeClr val="accent1"/>
+          </a:fillRef>
+          <a:effectRef idx="2">
+            <a:schemeClr val="accent1"/>
+          </a:effectRef>
+          <a:fontRef idx="minor">
+            <a:schemeClr val="lt1"/>
+          </a:fontRef>
+        </p:style>
+        <p:txBody>
+          <a:bodyPr rtlCol="0" anchor="ctr"/>
+          <a:lstStyle/>
+          <a:p/>
+        </p:txBody>
+      </p:sp>
+      <p:sp>
+        <p:nvSpPr>
+          <p:cNvPr id="20" name="TextBox 19"/>
+          <p:cNvSpPr txBox="1"/>
+          <p:nvPr/>
+        </p:nvSpPr>
+        <p:spPr>
+          <a:xfrm>
+            <a:off x="777240" y="3410712"/>
+            <a:ext cx="2240280" cy="548640"/>
+          </a:xfrm>
+          <a:prstGeom prst="rect">
+            <a:avLst/>
+          </a:prstGeom>
+          <a:noFill/>
+        </p:spPr>
+        <p:txBody>
+          <a:bodyPr wrap="square" lIns="0" rIns="0" tIns="0" bIns="0" anchor="t">
+            <a:spAutoFit/>
+          </a:bodyPr>
+          <a:lstStyle/>
+          <a:p>
+            <a:pPr algn="l"/>
+            <a:r>
+              <a:rPr sz="1300" b="1" i="0">
+                <a:solidFill>
+                  <a:srgbClr val="003366"/>
+                </a:solidFill>
+                <a:latin typeface="Calibri"/>
+              </a:rPr>
+              <a:t>Flutterwave live keys</a:t>
+            </a:r>
+          </a:p>
+        </p:txBody>
+      </p:sp>
+      <p:sp>
+        <p:nvSpPr>
+          <p:cNvPr id="21" name="Rounded Rectangle 20"/>
+          <p:cNvSpPr/>
+          <p:nvPr/>
+        </p:nvSpPr>
+        <p:spPr>
+          <a:xfrm>
+            <a:off x="3154680" y="3429000"/>
+            <a:ext cx="777240" cy="256032"/>
+          </a:xfrm>
+          <a:prstGeom prst="roundRect">
+            <a:avLst>
+              <a:gd name="adj" fmla="val 50000"/>
+            </a:avLst>
+          </a:prstGeom>
+          <a:solidFill>
+            <a:srgbClr val="B23A2E"/>
+          </a:solidFill>
+          <a:ln>
+            <a:noFill/>
+          </a:ln>
+          <a:effectLst/>
+        </p:spPr>
+        <p:style>
+          <a:lnRef idx="1">
+            <a:schemeClr val="accent1"/>
+          </a:lnRef>
+          <a:fillRef idx="3">
+            <a:schemeClr val="accent1"/>
+          </a:fillRef>
+          <a:effectRef idx="2">
+            <a:schemeClr val="accent1"/>
+          </a:effectRef>
+          <a:fontRef idx="minor">
+            <a:schemeClr val="lt1"/>
+          </a:fontRef>
+        </p:style>
+        <p:txBody>
+          <a:bodyPr rtlCol="0" anchor="ctr" lIns="0" rIns="0" tIns="0" bIns="0"/>
+          <a:lstStyle/>
+          <a:p>
+            <a:pPr algn="ctr"/>
+            <a:r>
+              <a:rPr sz="800" b="1">
+                <a:solidFill>
+                  <a:srgbClr val="FFFFFF"/>
+                </a:solidFill>
+                <a:latin typeface="Calibri"/>
+              </a:rPr>
+              <a:t>OPEN</a:t>
+            </a:r>
+          </a:p>
+        </p:txBody>
+      </p:sp>
+      <p:sp>
+        <p:nvSpPr>
+          <p:cNvPr id="22" name="TextBox 21"/>
+          <p:cNvSpPr txBox="1"/>
+          <p:nvPr/>
+        </p:nvSpPr>
+        <p:spPr>
+          <a:xfrm>
+            <a:off x="777240" y="4023359"/>
+            <a:ext cx="3108960" cy="228600"/>
+          </a:xfrm>
+          <a:prstGeom prst="rect">
+            <a:avLst/>
+          </a:prstGeom>
+          <a:noFill/>
+        </p:spPr>
+        <p:txBody>
+          <a:bodyPr wrap="square" lIns="0" rIns="0" tIns="0" bIns="0" anchor="t">
+            <a:spAutoFit/>
+          </a:bodyPr>
+          <a:lstStyle/>
+          <a:p>
+            <a:pPr algn="l"/>
+            <a:r>
+              <a:rPr sz="850" b="1" i="0" spc="80">
+                <a:solidFill>
+                  <a:srgbClr val="7A8A9B"/>
+                </a:solidFill>
+                <a:latin typeface="Calibri"/>
+              </a:rPr>
+              <a:t>FINANCE</a:t>
+            </a:r>
+          </a:p>
+        </p:txBody>
+      </p:sp>
+      <p:sp>
+        <p:nvSpPr>
+          <p:cNvPr id="23" name="TextBox 22"/>
+          <p:cNvSpPr txBox="1"/>
+          <p:nvPr/>
+        </p:nvSpPr>
+        <p:spPr>
+          <a:xfrm>
+            <a:off x="777240" y="4224528"/>
+            <a:ext cx="3108960" cy="274320"/>
+          </a:xfrm>
+          <a:prstGeom prst="rect">
+            <a:avLst/>
+          </a:prstGeom>
+          <a:noFill/>
+        </p:spPr>
+        <p:txBody>
+          <a:bodyPr wrap="square" lIns="0" rIns="0" tIns="0" bIns="0" anchor="t">
+            <a:spAutoFit/>
+          </a:bodyPr>
+          <a:lstStyle/>
+          <a:p>
+            <a:pPr algn="l"/>
+            <a:r>
+              <a:rPr sz="1100" b="0" i="0">
+                <a:solidFill>
+                  <a:srgbClr val="1C2B3A"/>
+                </a:solidFill>
+                <a:latin typeface="Calibri"/>
+              </a:rPr>
+              <a:t>Verification in progress; blocks online payments</a:t>
+            </a:r>
+          </a:p>
+        </p:txBody>
+      </p:sp>
+      <p:sp>
+        <p:nvSpPr>
+          <p:cNvPr id="24" name="Rounded Rectangle 23"/>
+          <p:cNvSpPr/>
+          <p:nvPr/>
+        </p:nvSpPr>
+        <p:spPr>
+          <a:xfrm>
+            <a:off x="4297679" y="3246120"/>
+            <a:ext cx="3566160" cy="1280160"/>
+          </a:xfrm>
+          <a:prstGeom prst="roundRect">
+            <a:avLst>
+              <a:gd name="adj" fmla="val 6000"/>
+            </a:avLst>
+          </a:prstGeom>
+          <a:solidFill>
+            <a:srgbClr val="FFFFFF"/>
+          </a:solidFill>
+          <a:ln w="9525">
+            <a:solidFill>
+              <a:srgbClr val="D8E0EA"/>
+            </a:solidFill>
+          </a:ln>
+          <a:effectLst/>
+        </p:spPr>
+        <p:style>
+          <a:lnRef idx="1">
+            <a:schemeClr val="accent1"/>
+          </a:lnRef>
+          <a:fillRef idx="3">
+            <a:schemeClr val="accent1"/>
+          </a:fillRef>
+          <a:effectRef idx="2">
+            <a:schemeClr val="accent1"/>
+          </a:effectRef>
+          <a:fontRef idx="minor">
+            <a:schemeClr val="lt1"/>
+          </a:fontRef>
+        </p:style>
+        <p:txBody>
+          <a:bodyPr rtlCol="0" anchor="ctr"/>
+          <a:lstStyle/>
+          <a:p/>
+        </p:txBody>
+      </p:sp>
+      <p:sp>
+        <p:nvSpPr>
+          <p:cNvPr id="25" name="TextBox 24"/>
+          <p:cNvSpPr txBox="1"/>
+          <p:nvPr/>
+        </p:nvSpPr>
+        <p:spPr>
+          <a:xfrm>
+            <a:off x="4526279" y="3410712"/>
+            <a:ext cx="2240280" cy="548640"/>
+          </a:xfrm>
+          <a:prstGeom prst="rect">
+            <a:avLst/>
+          </a:prstGeom>
+          <a:noFill/>
+        </p:spPr>
+        <p:txBody>
+          <a:bodyPr wrap="square" lIns="0" rIns="0" tIns="0" bIns="0" anchor="t">
+            <a:spAutoFit/>
+          </a:bodyPr>
+          <a:lstStyle/>
+          <a:p>
+            <a:pPr algn="l"/>
+            <a:r>
+              <a:rPr sz="1300" b="1" i="0">
+                <a:solidFill>
+                  <a:srgbClr val="003366"/>
+                </a:solidFill>
+                <a:latin typeface="Calibri"/>
+              </a:rPr>
+              <a:t>Segregated client-funds accounts</a:t>
+            </a:r>
+          </a:p>
+        </p:txBody>
+      </p:sp>
+      <p:sp>
+        <p:nvSpPr>
+          <p:cNvPr id="26" name="Rounded Rectangle 25"/>
+          <p:cNvSpPr/>
+          <p:nvPr/>
+        </p:nvSpPr>
+        <p:spPr>
+          <a:xfrm>
+            <a:off x="6903720" y="3429000"/>
+            <a:ext cx="777240" cy="256032"/>
+          </a:xfrm>
+          <a:prstGeom prst="roundRect">
+            <a:avLst>
+              <a:gd name="adj" fmla="val 50000"/>
+            </a:avLst>
+          </a:prstGeom>
+          <a:solidFill>
+            <a:srgbClr val="1F7A4D"/>
+          </a:solidFill>
+          <a:ln>
+            <a:noFill/>
+          </a:ln>
+          <a:effectLst/>
+        </p:spPr>
+        <p:style>
+          <a:lnRef idx="1">
+            <a:schemeClr val="accent1"/>
+          </a:lnRef>
+          <a:fillRef idx="3">
+            <a:schemeClr val="accent1"/>
+          </a:fillRef>
+          <a:effectRef idx="2">
+            <a:schemeClr val="accent1"/>
+          </a:effectRef>
+          <a:fontRef idx="minor">
+            <a:schemeClr val="lt1"/>
+          </a:fontRef>
+        </p:style>
+        <p:txBody>
+          <a:bodyPr rtlCol="0" anchor="ctr" lIns="0" rIns="0" tIns="0" bIns="0"/>
+          <a:lstStyle/>
+          <a:p>
+            <a:pPr algn="ctr"/>
+            <a:r>
+              <a:rPr sz="800" b="1">
+                <a:solidFill>
+                  <a:srgbClr val="FFFFFF"/>
+                </a:solidFill>
+                <a:latin typeface="Calibri"/>
+              </a:rPr>
+              <a:t>DONE</a:t>
+            </a:r>
+          </a:p>
+        </p:txBody>
+      </p:sp>
+      <p:sp>
+        <p:nvSpPr>
+          <p:cNvPr id="27" name="TextBox 26"/>
+          <p:cNvSpPr txBox="1"/>
+          <p:nvPr/>
+        </p:nvSpPr>
+        <p:spPr>
+          <a:xfrm>
+            <a:off x="4526279" y="4023359"/>
+            <a:ext cx="3108960" cy="228600"/>
+          </a:xfrm>
+          <a:prstGeom prst="rect">
+            <a:avLst/>
+          </a:prstGeom>
+          <a:noFill/>
+        </p:spPr>
+        <p:txBody>
+          <a:bodyPr wrap="square" lIns="0" rIns="0" tIns="0" bIns="0" anchor="t">
+            <a:spAutoFit/>
+          </a:bodyPr>
+          <a:lstStyle/>
+          <a:p>
+            <a:pPr algn="l"/>
+            <a:r>
+              <a:rPr sz="850" b="1" i="0" spc="80">
+                <a:solidFill>
+                  <a:srgbClr val="7A8A9B"/>
+                </a:solidFill>
+                <a:latin typeface="Calibri"/>
+              </a:rPr>
+              <a:t>FINANCE</a:t>
+            </a:r>
+          </a:p>
+        </p:txBody>
+      </p:sp>
+      <p:sp>
+        <p:nvSpPr>
+          <p:cNvPr id="28" name="TextBox 27"/>
+          <p:cNvSpPr txBox="1"/>
+          <p:nvPr/>
+        </p:nvSpPr>
+        <p:spPr>
+          <a:xfrm>
+            <a:off x="4526279" y="4224528"/>
+            <a:ext cx="3108960" cy="274320"/>
+          </a:xfrm>
+          <a:prstGeom prst="rect">
+            <a:avLst/>
+          </a:prstGeom>
+          <a:noFill/>
+        </p:spPr>
+        <p:txBody>
+          <a:bodyPr wrap="square" lIns="0" rIns="0" tIns="0" bIns="0" anchor="t">
+            <a:spAutoFit/>
+          </a:bodyPr>
+          <a:lstStyle/>
+          <a:p>
+            <a:pPr algn="l"/>
+            <a:r>
+              <a:rPr sz="1100" b="0" i="0">
+                <a:solidFill>
+                  <a:srgbClr val="1C2B3A"/>
+                </a:solidFill>
+                <a:latin typeface="Calibri"/>
+              </a:rPr>
+              <a:t>Done 24 Sept: one per organisation</a:t>
+            </a:r>
+          </a:p>
+        </p:txBody>
+      </p:sp>
+      <p:sp>
+        <p:nvSpPr>
+          <p:cNvPr id="29" name="Rounded Rectangle 28"/>
+          <p:cNvSpPr/>
+          <p:nvPr/>
+        </p:nvSpPr>
+        <p:spPr>
+          <a:xfrm>
+            <a:off x="8046719" y="3246120"/>
+            <a:ext cx="3566160" cy="1280160"/>
+          </a:xfrm>
+          <a:prstGeom prst="roundRect">
+            <a:avLst>
+              <a:gd name="adj" fmla="val 6000"/>
+            </a:avLst>
+          </a:prstGeom>
+          <a:solidFill>
+            <a:srgbClr val="FFFFFF"/>
+          </a:solidFill>
+          <a:ln w="9525">
+            <a:solidFill>
+              <a:srgbClr val="D8E0EA"/>
+            </a:solidFill>
+          </a:ln>
+          <a:effectLst/>
+        </p:spPr>
+        <p:style>
+          <a:lnRef idx="1">
+            <a:schemeClr val="accent1"/>
+          </a:lnRef>
+          <a:fillRef idx="3">
+            <a:schemeClr val="accent1"/>
+          </a:fillRef>
+          <a:effectRef idx="2">
+            <a:schemeClr val="accent1"/>
+          </a:effectRef>
+          <a:fontRef idx="minor">
+            <a:schemeClr val="lt1"/>
+          </a:fontRef>
+        </p:style>
+        <p:txBody>
+          <a:bodyPr rtlCol="0" anchor="ctr"/>
+          <a:lstStyle/>
+          <a:p/>
+        </p:txBody>
+      </p:sp>
+      <p:sp>
+        <p:nvSpPr>
+          <p:cNvPr id="30" name="TextBox 29"/>
+          <p:cNvSpPr txBox="1"/>
+          <p:nvPr/>
+        </p:nvSpPr>
+        <p:spPr>
+          <a:xfrm>
+            <a:off x="8275319" y="3410712"/>
+            <a:ext cx="2240280" cy="548640"/>
+          </a:xfrm>
+          <a:prstGeom prst="rect">
+            <a:avLst/>
+          </a:prstGeom>
+          <a:noFill/>
+        </p:spPr>
+        <p:txBody>
+          <a:bodyPr wrap="square" lIns="0" rIns="0" tIns="0" bIns="0" anchor="t">
+            <a:spAutoFit/>
+          </a:bodyPr>
+          <a:lstStyle/>
+          <a:p>
+            <a:pPr algn="l"/>
+            <a:r>
+              <a:rPr sz="1300" b="1" i="0">
+                <a:solidFill>
+                  <a:srgbClr val="003366"/>
+                </a:solidFill>
+                <a:latin typeface="Calibri"/>
+              </a:rPr>
+              <a:t>Gateway minute (decision 4)</a:t>
+            </a:r>
+          </a:p>
+        </p:txBody>
+      </p:sp>
+      <p:sp>
+        <p:nvSpPr>
+          <p:cNvPr id="31" name="Rounded Rectangle 30"/>
+          <p:cNvSpPr/>
+          <p:nvPr/>
+        </p:nvSpPr>
+        <p:spPr>
+          <a:xfrm>
+            <a:off x="10652759" y="3429000"/>
+            <a:ext cx="777240" cy="256032"/>
+          </a:xfrm>
+          <a:prstGeom prst="roundRect">
+            <a:avLst>
+              <a:gd name="adj" fmla="val 50000"/>
+            </a:avLst>
+          </a:prstGeom>
+          <a:solidFill>
+            <a:srgbClr val="B5680A"/>
+          </a:solidFill>
+          <a:ln>
+            <a:noFill/>
+          </a:ln>
+          <a:effectLst/>
+        </p:spPr>
+        <p:style>
+          <a:lnRef idx="1">
+            <a:schemeClr val="accent1"/>
+          </a:lnRef>
+          <a:fillRef idx="3">
+            <a:schemeClr val="accent1"/>
+          </a:fillRef>
+          <a:effectRef idx="2">
+            <a:schemeClr val="accent1"/>
+          </a:effectRef>
+          <a:fontRef idx="minor">
+            <a:schemeClr val="lt1"/>
+          </a:fontRef>
+        </p:style>
+        <p:txBody>
+          <a:bodyPr rtlCol="0" anchor="ctr" lIns="0" rIns="0" tIns="0" bIns="0"/>
+          <a:lstStyle/>
+          <a:p>
+            <a:pPr algn="ctr"/>
+            <a:r>
+              <a:rPr sz="800" b="1">
+                <a:solidFill>
+                  <a:srgbClr val="FFFFFF"/>
+                </a:solidFill>
+                <a:latin typeface="Calibri"/>
+              </a:rPr>
+              <a:t>PART</a:t>
+            </a:r>
+          </a:p>
+        </p:txBody>
+      </p:sp>
+      <p:sp>
+        <p:nvSpPr>
+          <p:cNvPr id="32" name="TextBox 31"/>
+          <p:cNvSpPr txBox="1"/>
+          <p:nvPr/>
+        </p:nvSpPr>
+        <p:spPr>
+          <a:xfrm>
+            <a:off x="8275319" y="4023359"/>
+            <a:ext cx="3108960" cy="228600"/>
+          </a:xfrm>
+          <a:prstGeom prst="rect">
+            <a:avLst/>
+          </a:prstGeom>
+          <a:noFill/>
+        </p:spPr>
+        <p:txBody>
+          <a:bodyPr wrap="square" lIns="0" rIns="0" tIns="0" bIns="0" anchor="t">
+            <a:spAutoFit/>
+          </a:bodyPr>
+          <a:lstStyle/>
+          <a:p>
+            <a:pPr algn="l"/>
+            <a:r>
+              <a:rPr sz="850" b="1" i="0" spc="80">
+                <a:solidFill>
+                  <a:srgbClr val="7A8A9B"/>
+                </a:solidFill>
+                <a:latin typeface="Calibri"/>
+              </a:rPr>
+              <a:t>BOARD</a:t>
+            </a:r>
+          </a:p>
+        </p:txBody>
+      </p:sp>
+      <p:sp>
+        <p:nvSpPr>
+          <p:cNvPr id="33" name="TextBox 32"/>
+          <p:cNvSpPr txBox="1"/>
+          <p:nvPr/>
+        </p:nvSpPr>
+        <p:spPr>
+          <a:xfrm>
+            <a:off x="8275319" y="4224528"/>
+            <a:ext cx="3108960" cy="274320"/>
+          </a:xfrm>
+          <a:prstGeom prst="rect">
+            <a:avLst/>
+          </a:prstGeom>
+          <a:noFill/>
+        </p:spPr>
+        <p:txBody>
+          <a:bodyPr wrap="square" lIns="0" rIns="0" tIns="0" bIns="0" anchor="t">
+            <a:spAutoFit/>
+          </a:bodyPr>
+          <a:lstStyle/>
+          <a:p>
+            <a:pPr algn="l"/>
+            <a:r>
+              <a:rPr sz="1100" b="0" i="0">
+                <a:solidFill>
+                  <a:srgbClr val="1C2B3A"/>
+                </a:solidFill>
+                <a:latin typeface="Calibri"/>
+              </a:rPr>
+              <a:t>Drafted; awaiting signature</a:t>
+            </a:r>
+          </a:p>
+        </p:txBody>
+      </p:sp>
+      <p:sp>
+        <p:nvSpPr>
+          <p:cNvPr id="34" name="Rounded Rectangle 33"/>
+          <p:cNvSpPr/>
+          <p:nvPr/>
+        </p:nvSpPr>
+        <p:spPr>
+          <a:xfrm>
+            <a:off x="548640" y="4709159"/>
+            <a:ext cx="3566160" cy="1280160"/>
+          </a:xfrm>
+          <a:prstGeom prst="roundRect">
+            <a:avLst>
+              <a:gd name="adj" fmla="val 6000"/>
+            </a:avLst>
+          </a:prstGeom>
+          <a:solidFill>
+            <a:srgbClr val="FFFFFF"/>
+          </a:solidFill>
+          <a:ln w="9525">
+            <a:solidFill>
+              <a:srgbClr val="D8E0EA"/>
+            </a:solidFill>
+          </a:ln>
+          <a:effectLst/>
+        </p:spPr>
+        <p:style>
+          <a:lnRef idx="1">
+            <a:schemeClr val="accent1"/>
+          </a:lnRef>
+          <a:fillRef idx="3">
+            <a:schemeClr val="accent1"/>
+          </a:fillRef>
+          <a:effectRef idx="2">
+            <a:schemeClr val="accent1"/>
+          </a:effectRef>
+          <a:fontRef idx="minor">
+            <a:schemeClr val="lt1"/>
+          </a:fontRef>
+        </p:style>
+        <p:txBody>
+          <a:bodyPr rtlCol="0" anchor="ctr"/>
+          <a:lstStyle/>
+          <a:p/>
+        </p:txBody>
+      </p:sp>
+      <p:sp>
+        <p:nvSpPr>
+          <p:cNvPr id="35" name="TextBox 34"/>
+          <p:cNvSpPr txBox="1"/>
+          <p:nvPr/>
+        </p:nvSpPr>
+        <p:spPr>
+          <a:xfrm>
+            <a:off x="777240" y="4873751"/>
+            <a:ext cx="2240280" cy="548640"/>
+          </a:xfrm>
+          <a:prstGeom prst="rect">
+            <a:avLst/>
+          </a:prstGeom>
+          <a:noFill/>
+        </p:spPr>
+        <p:txBody>
+          <a:bodyPr wrap="square" lIns="0" rIns="0" tIns="0" bIns="0" anchor="t">
+            <a:spAutoFit/>
+          </a:bodyPr>
+          <a:lstStyle/>
+          <a:p>
+            <a:pPr algn="l"/>
+            <a:r>
+              <a:rPr sz="1300" b="1" i="0">
+                <a:solidFill>
+                  <a:srgbClr val="003366"/>
+                </a:solidFill>
+                <a:latin typeface="Calibri"/>
+              </a:rPr>
+              <a:t>Special-category data decision</a:t>
+            </a:r>
+          </a:p>
+        </p:txBody>
+      </p:sp>
+      <p:sp>
+        <p:nvSpPr>
+          <p:cNvPr id="36" name="Rounded Rectangle 35"/>
+          <p:cNvSpPr/>
+          <p:nvPr/>
+        </p:nvSpPr>
+        <p:spPr>
+          <a:xfrm>
+            <a:off x="3154680" y="4892040"/>
+            <a:ext cx="777240" cy="256032"/>
+          </a:xfrm>
+          <a:prstGeom prst="roundRect">
+            <a:avLst>
+              <a:gd name="adj" fmla="val 50000"/>
+            </a:avLst>
+          </a:prstGeom>
+          <a:solidFill>
+            <a:srgbClr val="B23A2E"/>
+          </a:solidFill>
+          <a:ln>
+            <a:noFill/>
+          </a:ln>
+          <a:effectLst/>
+        </p:spPr>
+        <p:style>
+          <a:lnRef idx="1">
+            <a:schemeClr val="accent1"/>
+          </a:lnRef>
+          <a:fillRef idx="3">
+            <a:schemeClr val="accent1"/>
+          </a:fillRef>
+          <a:effectRef idx="2">
+            <a:schemeClr val="accent1"/>
+          </a:effectRef>
+          <a:fontRef idx="minor">
+            <a:schemeClr val="lt1"/>
+          </a:fontRef>
+        </p:style>
+        <p:txBody>
+          <a:bodyPr rtlCol="0" anchor="ctr" lIns="0" rIns="0" tIns="0" bIns="0"/>
+          <a:lstStyle/>
+          <a:p>
+            <a:pPr algn="ctr"/>
+            <a:r>
+              <a:rPr sz="800" b="1">
+                <a:solidFill>
+                  <a:srgbClr val="FFFFFF"/>
+                </a:solidFill>
+                <a:latin typeface="Calibri"/>
+              </a:rPr>
+              <a:t>OPEN</a:t>
+            </a:r>
+          </a:p>
+        </p:txBody>
+      </p:sp>
+      <p:sp>
+        <p:nvSpPr>
+          <p:cNvPr id="37" name="TextBox 36"/>
+          <p:cNvSpPr txBox="1"/>
+          <p:nvPr/>
+        </p:nvSpPr>
+        <p:spPr>
+          <a:xfrm>
+            <a:off x="777240" y="5486399"/>
+            <a:ext cx="3108960" cy="228600"/>
+          </a:xfrm>
+          <a:prstGeom prst="rect">
+            <a:avLst/>
+          </a:prstGeom>
+          <a:noFill/>
+        </p:spPr>
+        <p:txBody>
+          <a:bodyPr wrap="square" lIns="0" rIns="0" tIns="0" bIns="0" anchor="t">
+            <a:spAutoFit/>
+          </a:bodyPr>
+          <a:lstStyle/>
+          <a:p>
+            <a:pPr algn="l"/>
+            <a:r>
+              <a:rPr sz="850" b="1" i="0" spc="80">
+                <a:solidFill>
+                  <a:srgbClr val="7A8A9B"/>
+                </a:solidFill>
+                <a:latin typeface="Calibri"/>
+              </a:rPr>
+              <a:t>BOARD</a:t>
+            </a:r>
+          </a:p>
+        </p:txBody>
+      </p:sp>
+      <p:sp>
+        <p:nvSpPr>
+          <p:cNvPr id="38" name="TextBox 37"/>
+          <p:cNvSpPr txBox="1"/>
+          <p:nvPr/>
+        </p:nvSpPr>
+        <p:spPr>
+          <a:xfrm>
+            <a:off x="777240" y="5687568"/>
+            <a:ext cx="3108960" cy="274320"/>
+          </a:xfrm>
+          <a:prstGeom prst="rect">
+            <a:avLst/>
+          </a:prstGeom>
+          <a:noFill/>
+        </p:spPr>
+        <p:txBody>
+          <a:bodyPr wrap="square" lIns="0" rIns="0" tIns="0" bIns="0" anchor="t">
+            <a:spAutoFit/>
+          </a:bodyPr>
+          <a:lstStyle/>
+          <a:p>
+            <a:pPr algn="l"/>
+            <a:r>
+              <a:rPr sz="1100" b="0" i="0">
+                <a:solidFill>
+                  <a:srgbClr val="1C2B3A"/>
+                </a:solidFill>
+                <a:latin typeface="Calibri"/>
+              </a:rPr>
+              <a:t>Not yet decided</a:t>
+            </a:r>
+          </a:p>
+        </p:txBody>
+      </p:sp>
+      <p:sp>
+        <p:nvSpPr>
+          <p:cNvPr id="39" name="Rounded Rectangle 38"/>
+          <p:cNvSpPr/>
+          <p:nvPr/>
+        </p:nvSpPr>
+        <p:spPr>
+          <a:xfrm>
+            <a:off x="4297679" y="4709159"/>
+            <a:ext cx="3566160" cy="1280160"/>
+          </a:xfrm>
+          <a:prstGeom prst="roundRect">
+            <a:avLst>
+              <a:gd name="adj" fmla="val 6000"/>
+            </a:avLst>
+          </a:prstGeom>
+          <a:solidFill>
+            <a:srgbClr val="FFFFFF"/>
+          </a:solidFill>
+          <a:ln w="9525">
+            <a:solidFill>
+              <a:srgbClr val="D8E0EA"/>
+            </a:solidFill>
+          </a:ln>
+          <a:effectLst/>
+        </p:spPr>
+        <p:style>
+          <a:lnRef idx="1">
+            <a:schemeClr val="accent1"/>
+          </a:lnRef>
+          <a:fillRef idx="3">
+            <a:schemeClr val="accent1"/>
+          </a:fillRef>
+          <a:effectRef idx="2">
+            <a:schemeClr val="accent1"/>
+          </a:effectRef>
+          <a:fontRef idx="minor">
+            <a:schemeClr val="lt1"/>
+          </a:fontRef>
+        </p:style>
+        <p:txBody>
+          <a:bodyPr rtlCol="0" anchor="ctr"/>
+          <a:lstStyle/>
+          <a:p/>
+        </p:txBody>
+      </p:sp>
+      <p:sp>
+        <p:nvSpPr>
+          <p:cNvPr id="40" name="TextBox 39"/>
+          <p:cNvSpPr txBox="1"/>
+          <p:nvPr/>
+        </p:nvSpPr>
+        <p:spPr>
+          <a:xfrm>
+            <a:off x="4526279" y="4873751"/>
+            <a:ext cx="2240280" cy="548640"/>
+          </a:xfrm>
+          <a:prstGeom prst="rect">
+            <a:avLst/>
+          </a:prstGeom>
+          <a:noFill/>
+        </p:spPr>
+        <p:txBody>
+          <a:bodyPr wrap="square" lIns="0" rIns="0" tIns="0" bIns="0" anchor="t">
+            <a:spAutoFit/>
+          </a:bodyPr>
+          <a:lstStyle/>
+          <a:p>
+            <a:pPr algn="l"/>
+            <a:r>
+              <a:rPr sz="1300" b="1" i="0">
+                <a:solidFill>
+                  <a:srgbClr val="003366"/>
+                </a:solidFill>
+                <a:latin typeface="Calibri"/>
+              </a:rPr>
+              <a:t>External penetration test</a:t>
+            </a:r>
+          </a:p>
+        </p:txBody>
+      </p:sp>
+      <p:sp>
+        <p:nvSpPr>
+          <p:cNvPr id="41" name="Rounded Rectangle 40"/>
+          <p:cNvSpPr/>
+          <p:nvPr/>
+        </p:nvSpPr>
+        <p:spPr>
+          <a:xfrm>
+            <a:off x="6903720" y="4892040"/>
+            <a:ext cx="777240" cy="256032"/>
+          </a:xfrm>
+          <a:prstGeom prst="roundRect">
+            <a:avLst>
+              <a:gd name="adj" fmla="val 50000"/>
+            </a:avLst>
+          </a:prstGeom>
+          <a:solidFill>
+            <a:srgbClr val="1F7A4D"/>
+          </a:solidFill>
+          <a:ln>
+            <a:noFill/>
+          </a:ln>
+          <a:effectLst/>
+        </p:spPr>
+        <p:style>
+          <a:lnRef idx="1">
+            <a:schemeClr val="accent1"/>
+          </a:lnRef>
+          <a:fillRef idx="3">
+            <a:schemeClr val="accent1"/>
+          </a:fillRef>
+          <a:effectRef idx="2">
+            <a:schemeClr val="accent1"/>
+          </a:effectRef>
+          <a:fontRef idx="minor">
+            <a:schemeClr val="lt1"/>
+          </a:fontRef>
+        </p:style>
+        <p:txBody>
+          <a:bodyPr rtlCol="0" anchor="ctr" lIns="0" rIns="0" tIns="0" bIns="0"/>
+          <a:lstStyle/>
+          <a:p>
+            <a:pPr algn="ctr"/>
+            <a:r>
+              <a:rPr sz="800" b="1">
+                <a:solidFill>
+                  <a:srgbClr val="FFFFFF"/>
+                </a:solidFill>
+                <a:latin typeface="Calibri"/>
+              </a:rPr>
+              <a:t>DONE</a:t>
+            </a:r>
+          </a:p>
+        </p:txBody>
+      </p:sp>
+      <p:sp>
+        <p:nvSpPr>
+          <p:cNvPr id="42" name="TextBox 41"/>
+          <p:cNvSpPr txBox="1"/>
+          <p:nvPr/>
+        </p:nvSpPr>
+        <p:spPr>
+          <a:xfrm>
+            <a:off x="4526279" y="5486399"/>
+            <a:ext cx="3108960" cy="228600"/>
+          </a:xfrm>
+          <a:prstGeom prst="rect">
+            <a:avLst/>
+          </a:prstGeom>
+          <a:noFill/>
+        </p:spPr>
+        <p:txBody>
+          <a:bodyPr wrap="square" lIns="0" rIns="0" tIns="0" bIns="0" anchor="t">
+            <a:spAutoFit/>
+          </a:bodyPr>
+          <a:lstStyle/>
+          <a:p>
+            <a:pPr algn="l"/>
+            <a:r>
+              <a:rPr sz="850" b="1" i="0" spc="80">
+                <a:solidFill>
+                  <a:srgbClr val="7A8A9B"/>
+                </a:solidFill>
+                <a:latin typeface="Calibri"/>
+              </a:rPr>
+              <a:t>BOARD</a:t>
+            </a:r>
+          </a:p>
+        </p:txBody>
+      </p:sp>
+      <p:sp>
+        <p:nvSpPr>
+          <p:cNvPr id="43" name="TextBox 42"/>
+          <p:cNvSpPr txBox="1"/>
+          <p:nvPr/>
+        </p:nvSpPr>
+        <p:spPr>
+          <a:xfrm>
+            <a:off x="4526279" y="5687568"/>
+            <a:ext cx="3108960" cy="274320"/>
+          </a:xfrm>
+          <a:prstGeom prst="rect">
+            <a:avLst/>
+          </a:prstGeom>
+          <a:noFill/>
+        </p:spPr>
+        <p:txBody>
+          <a:bodyPr wrap="square" lIns="0" rIns="0" tIns="0" bIns="0" anchor="t">
+            <a:spAutoFit/>
+          </a:bodyPr>
+          <a:lstStyle/>
+          <a:p>
+            <a:pPr algn="l"/>
+            <a:r>
+              <a:rPr sz="1100" b="0" i="0">
+                <a:solidFill>
+                  <a:srgbClr val="1C2B3A"/>
+                </a:solidFill>
+                <a:latin typeface="Calibri"/>
+              </a:rPr>
+              <a:t>Done; report to be filed</a:t>
+            </a:r>
+          </a:p>
+        </p:txBody>
+      </p:sp>
+      <p:sp>
+        <p:nvSpPr>
+          <p:cNvPr id="44" name="Rounded Rectangle 43"/>
+          <p:cNvSpPr/>
+          <p:nvPr/>
+        </p:nvSpPr>
+        <p:spPr>
+          <a:xfrm>
+            <a:off x="8046719" y="4709159"/>
+            <a:ext cx="3566160" cy="1280160"/>
+          </a:xfrm>
+          <a:prstGeom prst="roundRect">
+            <a:avLst>
+              <a:gd name="adj" fmla="val 6000"/>
+            </a:avLst>
+          </a:prstGeom>
+          <a:solidFill>
+            <a:srgbClr val="FFFFFF"/>
+          </a:solidFill>
+          <a:ln w="9525">
+            <a:solidFill>
+              <a:srgbClr val="D8E0EA"/>
+            </a:solidFill>
+          </a:ln>
+          <a:effectLst/>
+        </p:spPr>
+        <p:style>
+          <a:lnRef idx="1">
+            <a:schemeClr val="accent1"/>
+          </a:lnRef>
+          <a:fillRef idx="3">
+            <a:schemeClr val="accent1"/>
+          </a:fillRef>
+          <a:effectRef idx="2">
+            <a:schemeClr val="accent1"/>
+          </a:effectRef>
+          <a:fontRef idx="minor">
+            <a:schemeClr val="lt1"/>
+          </a:fontRef>
+        </p:style>
+        <p:txBody>
+          <a:bodyPr rtlCol="0" anchor="ctr"/>
+          <a:lstStyle/>
+          <a:p/>
+        </p:txBody>
+      </p:sp>
+      <p:sp>
+        <p:nvSpPr>
+          <p:cNvPr id="45" name="TextBox 44"/>
+          <p:cNvSpPr txBox="1"/>
+          <p:nvPr/>
+        </p:nvSpPr>
+        <p:spPr>
+          <a:xfrm>
+            <a:off x="8275319" y="4873751"/>
+            <a:ext cx="2240280" cy="548640"/>
+          </a:xfrm>
+          <a:prstGeom prst="rect">
+            <a:avLst/>
+          </a:prstGeom>
+          <a:noFill/>
+        </p:spPr>
+        <p:txBody>
+          <a:bodyPr wrap="square" lIns="0" rIns="0" tIns="0" bIns="0" anchor="t">
+            <a:spAutoFit/>
+          </a:bodyPr>
+          <a:lstStyle/>
+          <a:p>
+            <a:pPr algn="l"/>
+            <a:r>
+              <a:rPr sz="1300" b="1" i="0">
+                <a:solidFill>
+                  <a:srgbClr val="003366"/>
+                </a:solidFill>
+                <a:latin typeface="Calibri"/>
+              </a:rPr>
+              <a:t>Go-live date and GO</a:t>
+            </a:r>
+          </a:p>
+        </p:txBody>
+      </p:sp>
+      <p:sp>
+        <p:nvSpPr>
+          <p:cNvPr id="46" name="Rounded Rectangle 45"/>
+          <p:cNvSpPr/>
+          <p:nvPr/>
+        </p:nvSpPr>
+        <p:spPr>
+          <a:xfrm>
+            <a:off x="10652759" y="4892040"/>
+            <a:ext cx="777240" cy="256032"/>
+          </a:xfrm>
+          <a:prstGeom prst="roundRect">
+            <a:avLst>
+              <a:gd name="adj" fmla="val 50000"/>
+            </a:avLst>
+          </a:prstGeom>
+          <a:solidFill>
+            <a:srgbClr val="1F7A4D"/>
+          </a:solidFill>
+          <a:ln>
+            <a:noFill/>
+          </a:ln>
+          <a:effectLst/>
+        </p:spPr>
+        <p:style>
+          <a:lnRef idx="1">
+            <a:schemeClr val="accent1"/>
+          </a:lnRef>
+          <a:fillRef idx="3">
+            <a:schemeClr val="accent1"/>
+          </a:fillRef>
+          <a:effectRef idx="2">
+            <a:schemeClr val="accent1"/>
+          </a:effectRef>
+          <a:fontRef idx="minor">
+            <a:schemeClr val="lt1"/>
+          </a:fontRef>
+        </p:style>
+        <p:txBody>
+          <a:bodyPr rtlCol="0" anchor="ctr" lIns="0" rIns="0" tIns="0" bIns="0"/>
+          <a:lstStyle/>
+          <a:p>
+            <a:pPr algn="ctr"/>
+            <a:r>
+              <a:rPr sz="800" b="1">
+                <a:solidFill>
+                  <a:srgbClr val="FFFFFF"/>
+                </a:solidFill>
+                <a:latin typeface="Calibri"/>
+              </a:rPr>
+              <a:t>DONE</a:t>
+            </a:r>
+          </a:p>
+        </p:txBody>
+      </p:sp>
+      <p:sp>
+        <p:nvSpPr>
+          <p:cNvPr id="47" name="TextBox 46"/>
+          <p:cNvSpPr txBox="1"/>
+          <p:nvPr/>
+        </p:nvSpPr>
+        <p:spPr>
+          <a:xfrm>
+            <a:off x="8275319" y="5486399"/>
+            <a:ext cx="3108960" cy="228600"/>
+          </a:xfrm>
+          <a:prstGeom prst="rect">
+            <a:avLst/>
+          </a:prstGeom>
+          <a:noFill/>
+        </p:spPr>
+        <p:txBody>
+          <a:bodyPr wrap="square" lIns="0" rIns="0" tIns="0" bIns="0" anchor="t">
+            <a:spAutoFit/>
+          </a:bodyPr>
+          <a:lstStyle/>
+          <a:p>
+            <a:pPr algn="l"/>
+            <a:r>
+              <a:rPr sz="850" b="1" i="0" spc="80">
+                <a:solidFill>
+                  <a:srgbClr val="7A8A9B"/>
+                </a:solidFill>
+                <a:latin typeface="Calibri"/>
+              </a:rPr>
+              <a:t>BOARD</a:t>
+            </a:r>
+          </a:p>
+        </p:txBody>
+      </p:sp>
+      <p:sp>
+        <p:nvSpPr>
+          <p:cNvPr id="48" name="TextBox 47"/>
+          <p:cNvSpPr txBox="1"/>
+          <p:nvPr/>
+        </p:nvSpPr>
+        <p:spPr>
+          <a:xfrm>
+            <a:off x="8275319" y="5687568"/>
+            <a:ext cx="3108960" cy="274320"/>
+          </a:xfrm>
+          <a:prstGeom prst="rect">
+            <a:avLst/>
+          </a:prstGeom>
+          <a:noFill/>
+        </p:spPr>
+        <p:txBody>
+          <a:bodyPr wrap="square" lIns="0" rIns="0" tIns="0" bIns="0" anchor="t">
+            <a:spAutoFit/>
+          </a:bodyPr>
+          <a:lstStyle/>
+          <a:p>
+            <a:pPr algn="l"/>
+            <a:r>
+              <a:rPr sz="1100" b="0" i="0">
+                <a:solidFill>
+                  <a:srgbClr val="1C2B3A"/>
+                </a:solidFill>
+                <a:latin typeface="Calibri"/>
+              </a:rPr>
+              <a:t>GO given 28 Sept</a:t>
+            </a:r>
+          </a:p>
+        </p:txBody>
+      </p:sp>
+      <p:sp>
+        <p:nvSpPr>
+          <p:cNvPr id="49" name="TextBox 48"/>
+          <p:cNvSpPr txBox="1"/>
+          <p:nvPr/>
+        </p:nvSpPr>
+        <p:spPr>
+          <a:xfrm>
+            <a:off x="548640" y="6446520"/>
+            <a:ext cx="5486400" cy="228600"/>
+          </a:xfrm>
+          <a:prstGeom prst="rect">
+            <a:avLst/>
+          </a:prstGeom>
+          <a:noFill/>
+        </p:spPr>
+        <p:txBody>
+          <a:bodyPr wrap="square" lIns="0" rIns="0" tIns="0" bIns="0" anchor="t">
+            <a:spAutoFit/>
+          </a:bodyPr>
+          <a:lstStyle/>
+          <a:p>
+            <a:pPr algn="l"/>
+            <a:r>
+              <a:rPr sz="900" b="0" i="0">
+                <a:solidFill>
+                  <a:srgbClr val="7A8A9B"/>
+                </a:solidFill>
+                <a:latin typeface="Calibri"/>
+              </a:rPr>
+              <a:t>Board Confidential  ·  29 September 2026</a:t>
+            </a:r>
+          </a:p>
+        </p:txBody>
+      </p:sp>
+    </p:spTree>
+  </p:cSld>
+  <p:clrMapOvr>
+    <a:masterClrMapping/>
+  </p:clrMapOvr>
+</p:sld>
+</file>
+
+<file path=ppt/slides/slide11.xml><?xml version="1.0" encoding="utf-8"?>
+<p:sld xmlns:a="http://schemas.openxmlformats.org/drawingml/2006/main" xmlns:p="http://schemas.openxmlformats.org/presentationml/2006/main" xmlns:r="http://schemas.openxmlformats.org/officeDocument/2006/relationships">
+  <p:cSld>
+    <p:bg>
+      <p:bgPr>
+        <a:solidFill>
           <a:srgbClr val="0A1B2E"/>
         </a:solidFill>
         <a:effectLst/>
@@ -15728,7 +17784,7 @@
                 </a:solidFill>
                 <a:latin typeface="Cambria"/>
               </a:rPr>
-              <a:t>The board's items — what is done and what is still open</a:t>
+              <a:t>What it costs to keep running, every month</a:t>
             </a:r>
           </a:p>
         </p:txBody>
@@ -15763,21 +17819,474 @@
                 </a:solidFill>
                 <a:latin typeface="Calibri"/>
               </a:rPr>
-              <a:t>Go-live was authorised with the open items below as a deliberate decision. Each still needs an owner and a date.</a:t>
-            </a:r>
-          </a:p>
-        </p:txBody>
-      </p:sp>
-      <p:sp>
-        <p:nvSpPr>
-          <p:cNvPr id="4" name="Rounded Rectangle 3"/>
+              <a:t>Recurrent cost after go-live, from the Production Readiness report (3 Sept), updated for decisions since.</a:t>
+            </a:r>
+          </a:p>
+        </p:txBody>
+      </p:sp>
+      <p:graphicFrame>
+        <p:nvGraphicFramePr>
+          <p:cNvPr id="4" name="Table 3"/>
+          <p:cNvGraphicFramePr>
+            <a:graphicFrameLocks noGrp="1"/>
+          </p:cNvGraphicFramePr>
+          <p:nvPr/>
+        </p:nvGraphicFramePr>
+        <p:xfrm>
+          <a:off x="548640" y="1783080"/>
+          <a:ext cx="6949440" cy="2898648"/>
+        </p:xfrm>
+        <a:graphic>
+          <a:graphicData uri="http://schemas.openxmlformats.org/drawingml/2006/table">
+            <a:tbl>
+              <a:tblPr firstRow="1" bandRow="1">
+                <a:tableStyleId>{5C22544A-7EE6-4342-B048-85BDC9FD1C3A}</a:tableStyleId>
+              </a:tblPr>
+              <a:tblGrid>
+                <a:gridCol w="1600200"/>
+                <a:gridCol w="3886200"/>
+                <a:gridCol w="1463040"/>
+              </a:tblGrid>
+              <a:tr h="384048">
+                <a:tc>
+                  <a:txBody>
+                    <a:bodyPr wrap="square"/>
+                    <a:lstStyle/>
+                    <a:p>
+                      <a:pPr algn="l"/>
+                      <a:r>
+                        <a:rPr sz="1000" b="1">
+                          <a:solidFill>
+                            <a:srgbClr val="FFFFFF"/>
+                          </a:solidFill>
+                          <a:latin typeface="Calibri"/>
+                        </a:rPr>
+                        <a:t>GROUP</a:t>
+                      </a:r>
+                    </a:p>
+                  </a:txBody>
+                  <a:tcPr marL="109728" marR="109728" marT="54864" marB="54864" anchor="ctr">
+                    <a:solidFill>
+                      <a:srgbClr val="003366"/>
+                    </a:solidFill>
+                  </a:tcPr>
+                </a:tc>
+                <a:tc>
+                  <a:txBody>
+                    <a:bodyPr wrap="square"/>
+                    <a:lstStyle/>
+                    <a:p>
+                      <a:pPr algn="l"/>
+                      <a:r>
+                        <a:rPr sz="1000" b="1">
+                          <a:solidFill>
+                            <a:srgbClr val="FFFFFF"/>
+                          </a:solidFill>
+                          <a:latin typeface="Calibri"/>
+                        </a:rPr>
+                        <a:t>SERVICES</a:t>
+                      </a:r>
+                    </a:p>
+                  </a:txBody>
+                  <a:tcPr marL="109728" marR="109728" marT="54864" marB="54864" anchor="ctr">
+                    <a:solidFill>
+                      <a:srgbClr val="003366"/>
+                    </a:solidFill>
+                  </a:tcPr>
+                </a:tc>
+                <a:tc>
+                  <a:txBody>
+                    <a:bodyPr wrap="square"/>
+                    <a:lstStyle/>
+                    <a:p>
+                      <a:pPr algn="r"/>
+                      <a:r>
+                        <a:rPr sz="1000" b="1">
+                          <a:solidFill>
+                            <a:srgbClr val="FFFFFF"/>
+                          </a:solidFill>
+                          <a:latin typeface="Calibri"/>
+                        </a:rPr>
+                        <a:t>₦ / MONTH</a:t>
+                      </a:r>
+                    </a:p>
+                  </a:txBody>
+                  <a:tcPr marL="109728" marR="109728" marT="54864" marB="54864" anchor="ctr">
+                    <a:solidFill>
+                      <a:srgbClr val="003366"/>
+                    </a:solidFill>
+                  </a:tcPr>
+                </a:tc>
+              </a:tr>
+              <a:tr h="502920">
+                <a:tc>
+                  <a:txBody>
+                    <a:bodyPr wrap="square"/>
+                    <a:lstStyle/>
+                    <a:p>
+                      <a:pPr algn="l"/>
+                      <a:r>
+                        <a:rPr sz="1150" b="1">
+                          <a:solidFill>
+                            <a:srgbClr val="003366"/>
+                          </a:solidFill>
+                          <a:latin typeface="Calibri"/>
+                        </a:rPr>
+                        <a:t>Platform &amp; data</a:t>
+                      </a:r>
+                    </a:p>
+                  </a:txBody>
+                  <a:tcPr marL="109728" marR="109728" marT="54864" marB="54864" anchor="ctr">
+                    <a:solidFill>
+                      <a:srgbClr val="FFFFFF"/>
+                    </a:solidFill>
+                  </a:tcPr>
+                </a:tc>
+                <a:tc>
+                  <a:txBody>
+                    <a:bodyPr wrap="square"/>
+                    <a:lstStyle/>
+                    <a:p>
+                      <a:pPr algn="l"/>
+                      <a:r>
+                        <a:rPr sz="1100" b="0">
+                          <a:solidFill>
+                            <a:srgbClr val="1C2B3A"/>
+                          </a:solidFill>
+                          <a:latin typeface="Calibri"/>
+                        </a:rPr>
+                        <a:t>Supabase · Vercel · Cloudflare (incl. CAPTCHA) · Upstash · Infisical</a:t>
+                      </a:r>
+                    </a:p>
+                  </a:txBody>
+                  <a:tcPr marL="109728" marR="109728" marT="54864" marB="54864" anchor="ctr">
+                    <a:solidFill>
+                      <a:srgbClr val="FFFFFF"/>
+                    </a:solidFill>
+                  </a:tcPr>
+                </a:tc>
+                <a:tc>
+                  <a:txBody>
+                    <a:bodyPr wrap="square"/>
+                    <a:lstStyle/>
+                    <a:p>
+                      <a:pPr algn="r"/>
+                      <a:r>
+                        <a:rPr sz="1150" b="0">
+                          <a:solidFill>
+                            <a:srgbClr val="1C2B3A"/>
+                          </a:solidFill>
+                          <a:latin typeface="Calibri"/>
+                        </a:rPr>
+                        <a:t>₦215,200</a:t>
+                      </a:r>
+                    </a:p>
+                  </a:txBody>
+                  <a:tcPr marL="109728" marR="109728" marT="54864" marB="54864" anchor="ctr">
+                    <a:solidFill>
+                      <a:srgbClr val="FFFFFF"/>
+                    </a:solidFill>
+                  </a:tcPr>
+                </a:tc>
+              </a:tr>
+              <a:tr h="502920">
+                <a:tc>
+                  <a:txBody>
+                    <a:bodyPr wrap="square"/>
+                    <a:lstStyle/>
+                    <a:p>
+                      <a:pPr algn="l"/>
+                      <a:r>
+                        <a:rPr sz="1150" b="1">
+                          <a:solidFill>
+                            <a:srgbClr val="003366"/>
+                          </a:solidFill>
+                          <a:latin typeface="Calibri"/>
+                        </a:rPr>
+                        <a:t>Monitoring</a:t>
+                      </a:r>
+                    </a:p>
+                  </a:txBody>
+                  <a:tcPr marL="109728" marR="109728" marT="54864" marB="54864" anchor="ctr">
+                    <a:solidFill>
+                      <a:srgbClr val="F7F9FC"/>
+                    </a:solidFill>
+                  </a:tcPr>
+                </a:tc>
+                <a:tc>
+                  <a:txBody>
+                    <a:bodyPr wrap="square"/>
+                    <a:lstStyle/>
+                    <a:p>
+                      <a:pPr algn="l"/>
+                      <a:r>
+                        <a:rPr sz="1100" b="0">
+                          <a:solidFill>
+                            <a:srgbClr val="1C2B3A"/>
+                          </a:solidFill>
+                          <a:latin typeface="Calibri"/>
+                        </a:rPr>
+                        <a:t>Sentry · Better Uptime (optional)</a:t>
+                      </a:r>
+                    </a:p>
+                  </a:txBody>
+                  <a:tcPr marL="109728" marR="109728" marT="54864" marB="54864" anchor="ctr">
+                    <a:solidFill>
+                      <a:srgbClr val="F7F9FC"/>
+                    </a:solidFill>
+                  </a:tcPr>
+                </a:tc>
+                <a:tc>
+                  <a:txBody>
+                    <a:bodyPr wrap="square"/>
+                    <a:lstStyle/>
+                    <a:p>
+                      <a:pPr algn="r"/>
+                      <a:r>
+                        <a:rPr sz="1150" b="0">
+                          <a:solidFill>
+                            <a:srgbClr val="1C2B3A"/>
+                          </a:solidFill>
+                          <a:latin typeface="Calibri"/>
+                        </a:rPr>
+                        <a:t>₦42,450</a:t>
+                      </a:r>
+                    </a:p>
+                  </a:txBody>
+                  <a:tcPr marL="109728" marR="109728" marT="54864" marB="54864" anchor="ctr">
+                    <a:solidFill>
+                      <a:srgbClr val="F7F9FC"/>
+                    </a:solidFill>
+                  </a:tcPr>
+                </a:tc>
+              </a:tr>
+              <a:tr h="502920">
+                <a:tc>
+                  <a:txBody>
+                    <a:bodyPr wrap="square"/>
+                    <a:lstStyle/>
+                    <a:p>
+                      <a:pPr algn="l"/>
+                      <a:r>
+                        <a:rPr sz="1150" b="1">
+                          <a:solidFill>
+                            <a:srgbClr val="003366"/>
+                          </a:solidFill>
+                          <a:latin typeface="Calibri"/>
+                        </a:rPr>
+                        <a:t>Automation &amp; AI</a:t>
+                      </a:r>
+                    </a:p>
+                  </a:txBody>
+                  <a:tcPr marL="109728" marR="109728" marT="54864" marB="54864" anchor="ctr">
+                    <a:solidFill>
+                      <a:srgbClr val="FFFFFF"/>
+                    </a:solidFill>
+                  </a:tcPr>
+                </a:tc>
+                <a:tc>
+                  <a:txBody>
+                    <a:bodyPr wrap="square"/>
+                    <a:lstStyle/>
+                    <a:p>
+                      <a:pPr algn="l"/>
+                      <a:r>
+                        <a:rPr sz="1100" b="0">
+                          <a:solidFill>
+                            <a:srgbClr val="1C2B3A"/>
+                          </a:solidFill>
+                          <a:latin typeface="Calibri"/>
+                        </a:rPr>
+                        <a:t>Claude API (usage) · Gemini fallback (free tier)</a:t>
+                      </a:r>
+                    </a:p>
+                  </a:txBody>
+                  <a:tcPr marL="109728" marR="109728" marT="54864" marB="54864" anchor="ctr">
+                    <a:solidFill>
+                      <a:srgbClr val="FFFFFF"/>
+                    </a:solidFill>
+                  </a:tcPr>
+                </a:tc>
+                <a:tc>
+                  <a:txBody>
+                    <a:bodyPr wrap="square"/>
+                    <a:lstStyle/>
+                    <a:p>
+                      <a:pPr algn="r"/>
+                      <a:r>
+                        <a:rPr sz="1150" b="0">
+                          <a:solidFill>
+                            <a:srgbClr val="1C2B3A"/>
+                          </a:solidFill>
+                          <a:latin typeface="Calibri"/>
+                        </a:rPr>
+                        <a:t>₦100,350</a:t>
+                      </a:r>
+                    </a:p>
+                  </a:txBody>
+                  <a:tcPr marL="109728" marR="109728" marT="54864" marB="54864" anchor="ctr">
+                    <a:solidFill>
+                      <a:srgbClr val="FFFFFF"/>
+                    </a:solidFill>
+                  </a:tcPr>
+                </a:tc>
+              </a:tr>
+              <a:tr h="502920">
+                <a:tc>
+                  <a:txBody>
+                    <a:bodyPr wrap="square"/>
+                    <a:lstStyle/>
+                    <a:p>
+                      <a:pPr algn="l"/>
+                      <a:r>
+                        <a:rPr sz="1150" b="1">
+                          <a:solidFill>
+                            <a:srgbClr val="003366"/>
+                          </a:solidFill>
+                          <a:latin typeface="Calibri"/>
+                        </a:rPr>
+                        <a:t>Channels</a:t>
+                      </a:r>
+                    </a:p>
+                  </a:txBody>
+                  <a:tcPr marL="109728" marR="109728" marT="54864" marB="54864" anchor="ctr">
+                    <a:solidFill>
+                      <a:srgbClr val="F7F9FC"/>
+                    </a:solidFill>
+                  </a:tcPr>
+                </a:tc>
+                <a:tc>
+                  <a:txBody>
+                    <a:bodyPr wrap="square"/>
+                    <a:lstStyle/>
+                    <a:p>
+                      <a:pPr algn="l"/>
+                      <a:r>
+                        <a:rPr sz="1100" b="0">
+                          <a:solidFill>
+                            <a:srgbClr val="1C2B3A"/>
+                          </a:solidFill>
+                          <a:latin typeface="Calibri"/>
+                        </a:rPr>
+                        <a:t>WhatsApp (360dialog) · Resend email · SMS fallback</a:t>
+                      </a:r>
+                    </a:p>
+                  </a:txBody>
+                  <a:tcPr marL="109728" marR="109728" marT="54864" marB="54864" anchor="ctr">
+                    <a:solidFill>
+                      <a:srgbClr val="F7F9FC"/>
+                    </a:solidFill>
+                  </a:tcPr>
+                </a:tc>
+                <a:tc>
+                  <a:txBody>
+                    <a:bodyPr wrap="square"/>
+                    <a:lstStyle/>
+                    <a:p>
+                      <a:pPr algn="r"/>
+                      <a:r>
+                        <a:rPr sz="1150" b="0">
+                          <a:solidFill>
+                            <a:srgbClr val="1C2B3A"/>
+                          </a:solidFill>
+                          <a:latin typeface="Calibri"/>
+                        </a:rPr>
+                        <a:t>₦158,375</a:t>
+                      </a:r>
+                    </a:p>
+                  </a:txBody>
+                  <a:tcPr marL="109728" marR="109728" marT="54864" marB="54864" anchor="ctr">
+                    <a:solidFill>
+                      <a:srgbClr val="F7F9FC"/>
+                    </a:solidFill>
+                  </a:tcPr>
+                </a:tc>
+              </a:tr>
+              <a:tr h="502920">
+                <a:tc>
+                  <a:txBody>
+                    <a:bodyPr wrap="square"/>
+                    <a:lstStyle/>
+                    <a:p>
+                      <a:pPr algn="l"/>
+                      <a:r>
+                        <a:rPr sz="1150" b="1">
+                          <a:solidFill>
+                            <a:srgbClr val="003366"/>
+                          </a:solidFill>
+                          <a:latin typeface="Calibri"/>
+                        </a:rPr>
+                        <a:t>TOTAL</a:t>
+                      </a:r>
+                    </a:p>
+                  </a:txBody>
+                  <a:tcPr marL="109728" marR="109728" marT="54864" marB="54864" anchor="ctr">
+                    <a:solidFill>
+                      <a:srgbClr val="EAF1F9"/>
+                    </a:solidFill>
+                  </a:tcPr>
+                </a:tc>
+                <a:tc>
+                  <a:txBody>
+                    <a:bodyPr wrap="square"/>
+                    <a:lstStyle/>
+                    <a:p>
+                      <a:pPr algn="l"/>
+                      <a:r>
+                        <a:rPr sz="1100" b="1">
+                          <a:solidFill>
+                            <a:srgbClr val="003366"/>
+                          </a:solidFill>
+                          <a:latin typeface="Calibri"/>
+                        </a:rPr>
+                        <a:t>Full stack, production tiers</a:t>
+                      </a:r>
+                    </a:p>
+                  </a:txBody>
+                  <a:tcPr marL="109728" marR="109728" marT="54864" marB="54864" anchor="ctr">
+                    <a:solidFill>
+                      <a:srgbClr val="EAF1F9"/>
+                    </a:solidFill>
+                  </a:tcPr>
+                </a:tc>
+                <a:tc>
+                  <a:txBody>
+                    <a:bodyPr wrap="square"/>
+                    <a:lstStyle/>
+                    <a:p>
+                      <a:pPr algn="r"/>
+                      <a:r>
+                        <a:rPr sz="1150" b="1">
+                          <a:solidFill>
+                            <a:srgbClr val="003366"/>
+                          </a:solidFill>
+                          <a:latin typeface="Calibri"/>
+                        </a:rPr>
+                        <a:t>₦516,375</a:t>
+                      </a:r>
+                    </a:p>
+                  </a:txBody>
+                  <a:tcPr marL="109728" marR="109728" marT="54864" marB="54864" anchor="ctr">
+                    <a:solidFill>
+                      <a:srgbClr val="EAF1F9"/>
+                    </a:solidFill>
+                  </a:tcPr>
+                </a:tc>
+              </a:tr>
+            </a:tbl>
+          </a:graphicData>
+        </a:graphic>
+      </p:graphicFrame>
+      <p:sp>
+        <p:nvSpPr>
+          <p:cNvPr id="5" name="Rounded Rectangle 4"/>
           <p:cNvSpPr/>
           <p:nvPr/>
         </p:nvSpPr>
         <p:spPr>
           <a:xfrm>
-            <a:off x="548640" y="1783080"/>
-            <a:ext cx="3566160" cy="1280160"/>
+            <a:off x="7772400" y="1783080"/>
+            <a:ext cx="3840480" cy="1417320"/>
           </a:xfrm>
           <a:prstGeom prst="roundRect">
             <a:avLst>
@@ -15816,14 +18325,14 @@
       </p:sp>
       <p:sp>
         <p:nvSpPr>
-          <p:cNvPr id="5" name="TextBox 4"/>
-          <p:cNvSpPr txBox="1"/>
-          <p:nvPr/>
-        </p:nvSpPr>
-        <p:spPr>
-          <a:xfrm>
-            <a:off x="777240" y="1947672"/>
-            <a:ext cx="2240280" cy="548640"/>
+          <p:cNvPr id="6" name="TextBox 5"/>
+          <p:cNvSpPr txBox="1"/>
+          <p:nvPr/>
+        </p:nvSpPr>
+        <p:spPr>
+          <a:xfrm>
+            <a:off x="8001000" y="1901952"/>
+            <a:ext cx="3474720" cy="548640"/>
           </a:xfrm>
           <a:prstGeom prst="rect">
             <a:avLst/>
@@ -15838,38 +18347,75 @@
           <a:p>
             <a:pPr algn="l"/>
             <a:r>
-              <a:rPr sz="1300" b="1" i="0">
+              <a:rPr sz="2600" b="1" i="0">
                 <a:solidFill>
                   <a:srgbClr val="003366"/>
                 </a:solidFill>
-                <a:latin typeface="Calibri"/>
-              </a:rPr>
-              <a:t>Processor agreements (14)</a:t>
-            </a:r>
-          </a:p>
-        </p:txBody>
-      </p:sp>
-      <p:sp>
-        <p:nvSpPr>
-          <p:cNvPr id="6" name="Rounded Rectangle 5"/>
+                <a:latin typeface="Cambria"/>
+              </a:rPr>
+              <a:t>≈ ₦516K / month</a:t>
+            </a:r>
+          </a:p>
+        </p:txBody>
+      </p:sp>
+      <p:sp>
+        <p:nvSpPr>
+          <p:cNvPr id="7" name="TextBox 6"/>
+          <p:cNvSpPr txBox="1"/>
+          <p:nvPr/>
+        </p:nvSpPr>
+        <p:spPr>
+          <a:xfrm>
+            <a:off x="8001000" y="2487168"/>
+            <a:ext cx="3474720" cy="640080"/>
+          </a:xfrm>
+          <a:prstGeom prst="rect">
+            <a:avLst/>
+          </a:prstGeom>
+          <a:noFill/>
+        </p:spPr>
+        <p:txBody>
+          <a:bodyPr wrap="square" lIns="0" rIns="0" tIns="0" bIns="0" anchor="t">
+            <a:spAutoFit/>
+          </a:bodyPr>
+          <a:lstStyle/>
+          <a:p>
+            <a:pPr algn="l"/>
+            <a:r>
+              <a:rPr sz="1150" b="0" i="0">
+                <a:solidFill>
+                  <a:srgbClr val="1C2B3A"/>
+                </a:solidFill>
+                <a:latin typeface="Calibri"/>
+              </a:rPr>
+              <a:t>Full stack at production tiers · ≈ ₦6.20M a year</a:t>
+            </a:r>
+          </a:p>
+        </p:txBody>
+      </p:sp>
+      <p:sp>
+        <p:nvSpPr>
+          <p:cNvPr id="8" name="Rounded Rectangle 7"/>
           <p:cNvSpPr/>
           <p:nvPr/>
         </p:nvSpPr>
         <p:spPr>
           <a:xfrm>
-            <a:off x="3154680" y="1965960"/>
-            <a:ext cx="777240" cy="256032"/>
+            <a:off x="7772400" y="3337560"/>
+            <a:ext cx="3840480" cy="1463040"/>
           </a:xfrm>
           <a:prstGeom prst="roundRect">
             <a:avLst>
-              <a:gd name="adj" fmla="val 50000"/>
+              <a:gd name="adj" fmla="val 6000"/>
             </a:avLst>
           </a:prstGeom>
           <a:solidFill>
-            <a:srgbClr val="B23A2E"/>
+            <a:srgbClr val="EAF1F9"/>
           </a:solidFill>
-          <a:ln>
-            <a:noFill/>
+          <a:ln w="9525">
+            <a:solidFill>
+              <a:srgbClr val="1F7A4D"/>
+            </a:solidFill>
           </a:ln>
           <a:effectLst/>
         </p:spPr>
@@ -15888,32 +18434,21 @@
           </a:fontRef>
         </p:style>
         <p:txBody>
-          <a:bodyPr rtlCol="0" anchor="ctr" lIns="0" rIns="0" tIns="0" bIns="0"/>
-          <a:lstStyle/>
-          <a:p>
-            <a:pPr algn="ctr"/>
-            <a:r>
-              <a:rPr sz="800" b="1">
-                <a:solidFill>
-                  <a:srgbClr val="FFFFFF"/>
-                </a:solidFill>
-                <a:latin typeface="Calibri"/>
-              </a:rPr>
-              <a:t>OPEN</a:t>
-            </a:r>
-          </a:p>
-        </p:txBody>
-      </p:sp>
-      <p:sp>
-        <p:nvSpPr>
-          <p:cNvPr id="7" name="TextBox 6"/>
-          <p:cNvSpPr txBox="1"/>
-          <p:nvPr/>
-        </p:nvSpPr>
-        <p:spPr>
-          <a:xfrm>
-            <a:off x="777240" y="2560320"/>
-            <a:ext cx="3108960" cy="228600"/>
+          <a:bodyPr rtlCol="0" anchor="ctr"/>
+          <a:lstStyle/>
+          <a:p/>
+        </p:txBody>
+      </p:sp>
+      <p:sp>
+        <p:nvSpPr>
+          <p:cNvPr id="9" name="TextBox 8"/>
+          <p:cNvSpPr txBox="1"/>
+          <p:nvPr/>
+        </p:nvSpPr>
+        <p:spPr>
+          <a:xfrm>
+            <a:off x="8001000" y="3456432"/>
+            <a:ext cx="3474720" cy="548640"/>
           </a:xfrm>
           <a:prstGeom prst="rect">
             <a:avLst/>
@@ -15928,27 +18463,27 @@
           <a:p>
             <a:pPr algn="l"/>
             <a:r>
-              <a:rPr sz="850" b="1" i="0" spc="80">
-                <a:solidFill>
-                  <a:srgbClr val="7A8A9B"/>
-                </a:solidFill>
-                <a:latin typeface="Calibri"/>
-              </a:rPr>
-              <a:t>LEGAL + DPO</a:t>
-            </a:r>
-          </a:p>
-        </p:txBody>
-      </p:sp>
-      <p:sp>
-        <p:nvSpPr>
-          <p:cNvPr id="8" name="TextBox 7"/>
-          <p:cNvSpPr txBox="1"/>
-          <p:nvPr/>
-        </p:nvSpPr>
-        <p:spPr>
-          <a:xfrm>
-            <a:off x="777240" y="2761488"/>
-            <a:ext cx="3108960" cy="274320"/>
+              <a:rPr sz="2600" b="1" i="0">
+                <a:solidFill>
+                  <a:srgbClr val="1F7A4D"/>
+                </a:solidFill>
+                <a:latin typeface="Cambria"/>
+              </a:rPr>
+              <a:t>≈ ₦408K / month</a:t>
+            </a:r>
+          </a:p>
+        </p:txBody>
+      </p:sp>
+      <p:sp>
+        <p:nvSpPr>
+          <p:cNvPr id="10" name="TextBox 9"/>
+          <p:cNvSpPr txBox="1"/>
+          <p:nvPr/>
+        </p:nvSpPr>
+        <p:spPr>
+          <a:xfrm>
+            <a:off x="8001000" y="4041648"/>
+            <a:ext cx="3474720" cy="731520"/>
           </a:xfrm>
           <a:prstGeom prst="rect">
             <a:avLst/>
@@ -15969,21 +18504,21 @@
                 </a:solidFill>
                 <a:latin typeface="Calibri"/>
               </a:rPr>
-              <a:t>Pack with counsel; none signed yet</a:t>
-            </a:r>
-          </a:p>
-        </p:txBody>
-      </p:sp>
-      <p:sp>
-        <p:nvSpPr>
-          <p:cNvPr id="9" name="Rounded Rectangle 8"/>
+              <a:t>Lean run-rate, ≈ ₦4.90M a year. Closest to what is live: SMS fallback out, Gemini on the free tier.</a:t>
+            </a:r>
+          </a:p>
+        </p:txBody>
+      </p:sp>
+      <p:sp>
+        <p:nvSpPr>
+          <p:cNvPr id="11" name="Rounded Rectangle 10"/>
           <p:cNvSpPr/>
           <p:nvPr/>
         </p:nvSpPr>
         <p:spPr>
           <a:xfrm>
-            <a:off x="4297679" y="1783080"/>
-            <a:ext cx="3566160" cy="1280160"/>
+            <a:off x="548640" y="5029200"/>
+            <a:ext cx="11064240" cy="1234440"/>
           </a:xfrm>
           <a:prstGeom prst="roundRect">
             <a:avLst>
@@ -16022,14 +18557,14 @@
       </p:sp>
       <p:sp>
         <p:nvSpPr>
-          <p:cNvPr id="10" name="TextBox 9"/>
-          <p:cNvSpPr txBox="1"/>
-          <p:nvPr/>
-        </p:nvSpPr>
-        <p:spPr>
-          <a:xfrm>
-            <a:off x="4526279" y="1947672"/>
-            <a:ext cx="2240280" cy="548640"/>
+          <p:cNvPr id="12" name="TextBox 11"/>
+          <p:cNvSpPr txBox="1"/>
+          <p:nvPr/>
+        </p:nvSpPr>
+        <p:spPr>
+          <a:xfrm>
+            <a:off x="777240" y="5138928"/>
+            <a:ext cx="2743200" cy="228600"/>
           </a:xfrm>
           <a:prstGeom prst="rect">
             <a:avLst/>
@@ -16044,130 +18579,53 @@
           <a:p>
             <a:pPr algn="l"/>
             <a:r>
-              <a:rPr sz="1300" b="1" i="0">
+              <a:rPr sz="950" b="1" i="0" spc="150">
+                <a:solidFill>
+                  <a:srgbClr val="C08A1E"/>
+                </a:solidFill>
+                <a:latin typeface="Calibri"/>
+              </a:rPr>
+              <a:t>NOT INCLUDED</a:t>
+            </a:r>
+          </a:p>
+        </p:txBody>
+      </p:sp>
+      <p:sp>
+        <p:nvSpPr>
+          <p:cNvPr id="13" name="TextBox 12"/>
+          <p:cNvSpPr txBox="1"/>
+          <p:nvPr/>
+        </p:nvSpPr>
+        <p:spPr>
+          <a:xfrm>
+            <a:off x="777240" y="5394960"/>
+            <a:ext cx="10607040" cy="822960"/>
+          </a:xfrm>
+          <a:prstGeom prst="rect">
+            <a:avLst/>
+          </a:prstGeom>
+          <a:noFill/>
+        </p:spPr>
+        <p:txBody>
+          <a:bodyPr wrap="square" lIns="0" rIns="0" tIns="0" bIns="0" anchor="t">
+            <a:spAutoFit/>
+          </a:bodyPr>
+          <a:lstStyle/>
+          <a:p>
+            <a:pPr algn="l">
+              <a:spcAft>
+                <a:spcPts val="300"/>
+              </a:spcAft>
+            </a:pPr>
+            <a:r>
+              <a:rPr sz="1100" b="1" i="0">
                 <a:solidFill>
                   <a:srgbClr val="003366"/>
                 </a:solidFill>
                 <a:latin typeface="Calibri"/>
               </a:rPr>
-              <a:t>Privacy notice</a:t>
-            </a:r>
-          </a:p>
-        </p:txBody>
-      </p:sp>
-      <p:sp>
-        <p:nvSpPr>
-          <p:cNvPr id="11" name="Rounded Rectangle 10"/>
-          <p:cNvSpPr/>
-          <p:nvPr/>
-        </p:nvSpPr>
-        <p:spPr>
-          <a:xfrm>
-            <a:off x="6903720" y="1965960"/>
-            <a:ext cx="777240" cy="256032"/>
-          </a:xfrm>
-          <a:prstGeom prst="roundRect">
-            <a:avLst>
-              <a:gd name="adj" fmla="val 50000"/>
-            </a:avLst>
-          </a:prstGeom>
-          <a:solidFill>
-            <a:srgbClr val="B5680A"/>
-          </a:solidFill>
-          <a:ln>
-            <a:noFill/>
-          </a:ln>
-          <a:effectLst/>
-        </p:spPr>
-        <p:style>
-          <a:lnRef idx="1">
-            <a:schemeClr val="accent1"/>
-          </a:lnRef>
-          <a:fillRef idx="3">
-            <a:schemeClr val="accent1"/>
-          </a:fillRef>
-          <a:effectRef idx="2">
-            <a:schemeClr val="accent1"/>
-          </a:effectRef>
-          <a:fontRef idx="minor">
-            <a:schemeClr val="lt1"/>
-          </a:fontRef>
-        </p:style>
-        <p:txBody>
-          <a:bodyPr rtlCol="0" anchor="ctr" lIns="0" rIns="0" tIns="0" bIns="0"/>
-          <a:lstStyle/>
-          <a:p>
-            <a:pPr algn="ctr"/>
-            <a:r>
-              <a:rPr sz="800" b="1">
-                <a:solidFill>
-                  <a:srgbClr val="FFFFFF"/>
-                </a:solidFill>
-                <a:latin typeface="Calibri"/>
-              </a:rPr>
-              <a:t>PART</a:t>
-            </a:r>
-          </a:p>
-        </p:txBody>
-      </p:sp>
-      <p:sp>
-        <p:nvSpPr>
-          <p:cNvPr id="12" name="TextBox 11"/>
-          <p:cNvSpPr txBox="1"/>
-          <p:nvPr/>
-        </p:nvSpPr>
-        <p:spPr>
-          <a:xfrm>
-            <a:off x="4526279" y="2560320"/>
-            <a:ext cx="3108960" cy="228600"/>
-          </a:xfrm>
-          <a:prstGeom prst="rect">
-            <a:avLst/>
-          </a:prstGeom>
-          <a:noFill/>
-        </p:spPr>
-        <p:txBody>
-          <a:bodyPr wrap="square" lIns="0" rIns="0" tIns="0" bIns="0" anchor="t">
-            <a:spAutoFit/>
-          </a:bodyPr>
-          <a:lstStyle/>
-          <a:p>
-            <a:pPr algn="l"/>
-            <a:r>
-              <a:rPr sz="850" b="1" i="0" spc="80">
-                <a:solidFill>
-                  <a:srgbClr val="7A8A9B"/>
-                </a:solidFill>
-                <a:latin typeface="Calibri"/>
-              </a:rPr>
-              <a:t>LEGAL</a:t>
-            </a:r>
-          </a:p>
-        </p:txBody>
-      </p:sp>
-      <p:sp>
-        <p:nvSpPr>
-          <p:cNvPr id="13" name="TextBox 12"/>
-          <p:cNvSpPr txBox="1"/>
-          <p:nvPr/>
-        </p:nvSpPr>
-        <p:spPr>
-          <a:xfrm>
-            <a:off x="4526279" y="2761488"/>
-            <a:ext cx="3108960" cy="274320"/>
-          </a:xfrm>
-          <a:prstGeom prst="rect">
-            <a:avLst/>
-          </a:prstGeom>
-          <a:noFill/>
-        </p:spPr>
-        <p:txBody>
-          <a:bodyPr wrap="square" lIns="0" rIns="0" tIns="0" bIns="0" anchor="t">
-            <a:spAutoFit/>
-          </a:bodyPr>
-          <a:lstStyle/>
-          <a:p>
-            <a:pPr algn="l"/>
+              <a:t>Gateway fees: </a:t>
+            </a:r>
             <a:r>
               <a:rPr sz="1100" b="0" i="0">
                 <a:solidFill>
@@ -16175,205 +18633,24 @@
                 </a:solidFill>
                 <a:latin typeface="Calibri"/>
               </a:rPr>
-              <a:t>Published 24 Sept; legal review owed</a:t>
-            </a:r>
-          </a:p>
-        </p:txBody>
-      </p:sp>
-      <p:sp>
-        <p:nvSpPr>
-          <p:cNvPr id="14" name="Rounded Rectangle 13"/>
-          <p:cNvSpPr/>
-          <p:nvPr/>
-        </p:nvSpPr>
-        <p:spPr>
-          <a:xfrm>
-            <a:off x="8046719" y="1783080"/>
-            <a:ext cx="3566160" cy="1280160"/>
-          </a:xfrm>
-          <a:prstGeom prst="roundRect">
-            <a:avLst>
-              <a:gd name="adj" fmla="val 6000"/>
-            </a:avLst>
-          </a:prstGeom>
-          <a:solidFill>
-            <a:srgbClr val="FFFFFF"/>
-          </a:solidFill>
-          <a:ln w="9525">
-            <a:solidFill>
-              <a:srgbClr val="D8E0EA"/>
-            </a:solidFill>
-          </a:ln>
-          <a:effectLst/>
-        </p:spPr>
-        <p:style>
-          <a:lnRef idx="1">
-            <a:schemeClr val="accent1"/>
-          </a:lnRef>
-          <a:fillRef idx="3">
-            <a:schemeClr val="accent1"/>
-          </a:fillRef>
-          <a:effectRef idx="2">
-            <a:schemeClr val="accent1"/>
-          </a:effectRef>
-          <a:fontRef idx="minor">
-            <a:schemeClr val="lt1"/>
-          </a:fontRef>
-        </p:style>
-        <p:txBody>
-          <a:bodyPr rtlCol="0" anchor="ctr"/>
-          <a:lstStyle/>
-          <a:p/>
-        </p:txBody>
-      </p:sp>
-      <p:sp>
-        <p:nvSpPr>
-          <p:cNvPr id="15" name="TextBox 14"/>
-          <p:cNvSpPr txBox="1"/>
-          <p:nvPr/>
-        </p:nvSpPr>
-        <p:spPr>
-          <a:xfrm>
-            <a:off x="8275319" y="1947672"/>
-            <a:ext cx="2240280" cy="548640"/>
-          </a:xfrm>
-          <a:prstGeom prst="rect">
-            <a:avLst/>
-          </a:prstGeom>
-          <a:noFill/>
-        </p:spPr>
-        <p:txBody>
-          <a:bodyPr wrap="square" lIns="0" rIns="0" tIns="0" bIns="0" anchor="t">
-            <a:spAutoFit/>
-          </a:bodyPr>
-          <a:lstStyle/>
-          <a:p>
-            <a:pPr algn="l"/>
-            <a:r>
-              <a:rPr sz="1300" b="1" i="0">
+              <a:t>Flutterwave now takes online collections (Naira and FX); its fees are per transaction, volume-driven and netted from collections. Paystack is switched off, so it costs nothing. Bank-transfer payments carry only ordinary bank charges.</a:t>
+            </a:r>
+          </a:p>
+          <a:p>
+            <a:pPr algn="l">
+              <a:spcAft>
+                <a:spcPts val="300"/>
+              </a:spcAft>
+            </a:pPr>
+            <a:r>
+              <a:rPr sz="1100" b="1" i="0">
                 <a:solidFill>
                   <a:srgbClr val="003366"/>
                 </a:solidFill>
                 <a:latin typeface="Calibri"/>
               </a:rPr>
-              <a:t>NDPC registration; DPO published</a:t>
-            </a:r>
-          </a:p>
-        </p:txBody>
-      </p:sp>
-      <p:sp>
-        <p:nvSpPr>
-          <p:cNvPr id="16" name="Rounded Rectangle 15"/>
-          <p:cNvSpPr/>
-          <p:nvPr/>
-        </p:nvSpPr>
-        <p:spPr>
-          <a:xfrm>
-            <a:off x="10652759" y="1965960"/>
-            <a:ext cx="777240" cy="256032"/>
-          </a:xfrm>
-          <a:prstGeom prst="roundRect">
-            <a:avLst>
-              <a:gd name="adj" fmla="val 50000"/>
-            </a:avLst>
-          </a:prstGeom>
-          <a:solidFill>
-            <a:srgbClr val="B23A2E"/>
-          </a:solidFill>
-          <a:ln>
-            <a:noFill/>
-          </a:ln>
-          <a:effectLst/>
-        </p:spPr>
-        <p:style>
-          <a:lnRef idx="1">
-            <a:schemeClr val="accent1"/>
-          </a:lnRef>
-          <a:fillRef idx="3">
-            <a:schemeClr val="accent1"/>
-          </a:fillRef>
-          <a:effectRef idx="2">
-            <a:schemeClr val="accent1"/>
-          </a:effectRef>
-          <a:fontRef idx="minor">
-            <a:schemeClr val="lt1"/>
-          </a:fontRef>
-        </p:style>
-        <p:txBody>
-          <a:bodyPr rtlCol="0" anchor="ctr" lIns="0" rIns="0" tIns="0" bIns="0"/>
-          <a:lstStyle/>
-          <a:p>
-            <a:pPr algn="ctr"/>
-            <a:r>
-              <a:rPr sz="800" b="1">
-                <a:solidFill>
-                  <a:srgbClr val="FFFFFF"/>
-                </a:solidFill>
-                <a:latin typeface="Calibri"/>
-              </a:rPr>
-              <a:t>OPEN</a:t>
-            </a:r>
-          </a:p>
-        </p:txBody>
-      </p:sp>
-      <p:sp>
-        <p:nvSpPr>
-          <p:cNvPr id="17" name="TextBox 16"/>
-          <p:cNvSpPr txBox="1"/>
-          <p:nvPr/>
-        </p:nvSpPr>
-        <p:spPr>
-          <a:xfrm>
-            <a:off x="8275319" y="2560320"/>
-            <a:ext cx="3108960" cy="228600"/>
-          </a:xfrm>
-          <a:prstGeom prst="rect">
-            <a:avLst/>
-          </a:prstGeom>
-          <a:noFill/>
-        </p:spPr>
-        <p:txBody>
-          <a:bodyPr wrap="square" lIns="0" rIns="0" tIns="0" bIns="0" anchor="t">
-            <a:spAutoFit/>
-          </a:bodyPr>
-          <a:lstStyle/>
-          <a:p>
-            <a:pPr algn="l"/>
-            <a:r>
-              <a:rPr sz="850" b="1" i="0" spc="80">
-                <a:solidFill>
-                  <a:srgbClr val="7A8A9B"/>
-                </a:solidFill>
-                <a:latin typeface="Calibri"/>
-              </a:rPr>
-              <a:t>LEGAL</a:t>
-            </a:r>
-          </a:p>
-        </p:txBody>
-      </p:sp>
-      <p:sp>
-        <p:nvSpPr>
-          <p:cNvPr id="18" name="TextBox 17"/>
-          <p:cNvSpPr txBox="1"/>
-          <p:nvPr/>
-        </p:nvSpPr>
-        <p:spPr>
-          <a:xfrm>
-            <a:off x="8275319" y="2761488"/>
-            <a:ext cx="3108960" cy="274320"/>
-          </a:xfrm>
-          <a:prstGeom prst="rect">
-            <a:avLst/>
-          </a:prstGeom>
-          <a:noFill/>
-        </p:spPr>
-        <p:txBody>
-          <a:bodyPr wrap="square" lIns="0" rIns="0" tIns="0" bIns="0" anchor="t">
-            <a:spAutoFit/>
-          </a:bodyPr>
-          <a:lstStyle/>
-          <a:p>
-            <a:pPr algn="l"/>
+              <a:t>If adopted later: </a:t>
+            </a:r>
             <a:r>
               <a:rPr sz="1100" b="0" i="0">
                 <a:solidFill>
@@ -16381,1250 +18658,14 @@
                 </a:solidFill>
                 <a:latin typeface="Calibri"/>
               </a:rPr>
-              <a:t>Not started</a:t>
-            </a:r>
-          </a:p>
-        </p:txBody>
-      </p:sp>
-      <p:sp>
-        <p:nvSpPr>
-          <p:cNvPr id="19" name="Rounded Rectangle 18"/>
-          <p:cNvSpPr/>
-          <p:nvPr/>
-        </p:nvSpPr>
-        <p:spPr>
-          <a:xfrm>
-            <a:off x="548640" y="3246120"/>
-            <a:ext cx="3566160" cy="1280160"/>
-          </a:xfrm>
-          <a:prstGeom prst="roundRect">
-            <a:avLst>
-              <a:gd name="adj" fmla="val 6000"/>
-            </a:avLst>
-          </a:prstGeom>
-          <a:solidFill>
-            <a:srgbClr val="FFFFFF"/>
-          </a:solidFill>
-          <a:ln w="9525">
-            <a:solidFill>
-              <a:srgbClr val="D8E0EA"/>
-            </a:solidFill>
-          </a:ln>
-          <a:effectLst/>
-        </p:spPr>
-        <p:style>
-          <a:lnRef idx="1">
-            <a:schemeClr val="accent1"/>
-          </a:lnRef>
-          <a:fillRef idx="3">
-            <a:schemeClr val="accent1"/>
-          </a:fillRef>
-          <a:effectRef idx="2">
-            <a:schemeClr val="accent1"/>
-          </a:effectRef>
-          <a:fontRef idx="minor">
-            <a:schemeClr val="lt1"/>
-          </a:fontRef>
-        </p:style>
-        <p:txBody>
-          <a:bodyPr rtlCol="0" anchor="ctr"/>
-          <a:lstStyle/>
-          <a:p/>
-        </p:txBody>
-      </p:sp>
-      <p:sp>
-        <p:nvSpPr>
-          <p:cNvPr id="20" name="TextBox 19"/>
-          <p:cNvSpPr txBox="1"/>
-          <p:nvPr/>
-        </p:nvSpPr>
-        <p:spPr>
-          <a:xfrm>
-            <a:off x="777240" y="3410712"/>
-            <a:ext cx="2240280" cy="548640"/>
-          </a:xfrm>
-          <a:prstGeom prst="rect">
-            <a:avLst/>
-          </a:prstGeom>
-          <a:noFill/>
-        </p:spPr>
-        <p:txBody>
-          <a:bodyPr wrap="square" lIns="0" rIns="0" tIns="0" bIns="0" anchor="t">
-            <a:spAutoFit/>
-          </a:bodyPr>
-          <a:lstStyle/>
-          <a:p>
-            <a:pPr algn="l"/>
-            <a:r>
-              <a:rPr sz="1300" b="1" i="0">
-                <a:solidFill>
-                  <a:srgbClr val="003366"/>
-                </a:solidFill>
-                <a:latin typeface="Calibri"/>
-              </a:rPr>
-              <a:t>Flutterwave live keys</a:t>
-            </a:r>
-          </a:p>
-        </p:txBody>
-      </p:sp>
-      <p:sp>
-        <p:nvSpPr>
-          <p:cNvPr id="21" name="Rounded Rectangle 20"/>
-          <p:cNvSpPr/>
-          <p:nvPr/>
-        </p:nvSpPr>
-        <p:spPr>
-          <a:xfrm>
-            <a:off x="3154680" y="3429000"/>
-            <a:ext cx="777240" cy="256032"/>
-          </a:xfrm>
-          <a:prstGeom prst="roundRect">
-            <a:avLst>
-              <a:gd name="adj" fmla="val 50000"/>
-            </a:avLst>
-          </a:prstGeom>
-          <a:solidFill>
-            <a:srgbClr val="B23A2E"/>
-          </a:solidFill>
-          <a:ln>
-            <a:noFill/>
-          </a:ln>
-          <a:effectLst/>
-        </p:spPr>
-        <p:style>
-          <a:lnRef idx="1">
-            <a:schemeClr val="accent1"/>
-          </a:lnRef>
-          <a:fillRef idx="3">
-            <a:schemeClr val="accent1"/>
-          </a:fillRef>
-          <a:effectRef idx="2">
-            <a:schemeClr val="accent1"/>
-          </a:effectRef>
-          <a:fontRef idx="minor">
-            <a:schemeClr val="lt1"/>
-          </a:fontRef>
-        </p:style>
-        <p:txBody>
-          <a:bodyPr rtlCol="0" anchor="ctr" lIns="0" rIns="0" tIns="0" bIns="0"/>
-          <a:lstStyle/>
-          <a:p>
-            <a:pPr algn="ctr"/>
-            <a:r>
-              <a:rPr sz="800" b="1">
-                <a:solidFill>
-                  <a:srgbClr val="FFFFFF"/>
-                </a:solidFill>
-                <a:latin typeface="Calibri"/>
-              </a:rPr>
-              <a:t>OPEN</a:t>
-            </a:r>
-          </a:p>
-        </p:txBody>
-      </p:sp>
-      <p:sp>
-        <p:nvSpPr>
-          <p:cNvPr id="22" name="TextBox 21"/>
-          <p:cNvSpPr txBox="1"/>
-          <p:nvPr/>
-        </p:nvSpPr>
-        <p:spPr>
-          <a:xfrm>
-            <a:off x="777240" y="4023359"/>
-            <a:ext cx="3108960" cy="228600"/>
-          </a:xfrm>
-          <a:prstGeom prst="rect">
-            <a:avLst/>
-          </a:prstGeom>
-          <a:noFill/>
-        </p:spPr>
-        <p:txBody>
-          <a:bodyPr wrap="square" lIns="0" rIns="0" tIns="0" bIns="0" anchor="t">
-            <a:spAutoFit/>
-          </a:bodyPr>
-          <a:lstStyle/>
-          <a:p>
-            <a:pPr algn="l"/>
-            <a:r>
-              <a:rPr sz="850" b="1" i="0" spc="80">
-                <a:solidFill>
-                  <a:srgbClr val="7A8A9B"/>
-                </a:solidFill>
-                <a:latin typeface="Calibri"/>
-              </a:rPr>
-              <a:t>FINANCE</a:t>
-            </a:r>
-          </a:p>
-        </p:txBody>
-      </p:sp>
-      <p:sp>
-        <p:nvSpPr>
-          <p:cNvPr id="23" name="TextBox 22"/>
-          <p:cNvSpPr txBox="1"/>
-          <p:nvPr/>
-        </p:nvSpPr>
-        <p:spPr>
-          <a:xfrm>
-            <a:off x="777240" y="4224528"/>
-            <a:ext cx="3108960" cy="274320"/>
-          </a:xfrm>
-          <a:prstGeom prst="rect">
-            <a:avLst/>
-          </a:prstGeom>
-          <a:noFill/>
-        </p:spPr>
-        <p:txBody>
-          <a:bodyPr wrap="square" lIns="0" rIns="0" tIns="0" bIns="0" anchor="t">
-            <a:spAutoFit/>
-          </a:bodyPr>
-          <a:lstStyle/>
-          <a:p>
-            <a:pPr algn="l"/>
-            <a:r>
-              <a:rPr sz="1100" b="0" i="0">
-                <a:solidFill>
-                  <a:srgbClr val="1C2B3A"/>
-                </a:solidFill>
-                <a:latin typeface="Calibri"/>
-              </a:rPr>
-              <a:t>Verification in progress; blocks online payments</a:t>
-            </a:r>
-          </a:p>
-        </p:txBody>
-      </p:sp>
-      <p:sp>
-        <p:nvSpPr>
-          <p:cNvPr id="24" name="Rounded Rectangle 23"/>
-          <p:cNvSpPr/>
-          <p:nvPr/>
-        </p:nvSpPr>
-        <p:spPr>
-          <a:xfrm>
-            <a:off x="4297679" y="3246120"/>
-            <a:ext cx="3566160" cy="1280160"/>
-          </a:xfrm>
-          <a:prstGeom prst="roundRect">
-            <a:avLst>
-              <a:gd name="adj" fmla="val 6000"/>
-            </a:avLst>
-          </a:prstGeom>
-          <a:solidFill>
-            <a:srgbClr val="FFFFFF"/>
-          </a:solidFill>
-          <a:ln w="9525">
-            <a:solidFill>
-              <a:srgbClr val="D8E0EA"/>
-            </a:solidFill>
-          </a:ln>
-          <a:effectLst/>
-        </p:spPr>
-        <p:style>
-          <a:lnRef idx="1">
-            <a:schemeClr val="accent1"/>
-          </a:lnRef>
-          <a:fillRef idx="3">
-            <a:schemeClr val="accent1"/>
-          </a:fillRef>
-          <a:effectRef idx="2">
-            <a:schemeClr val="accent1"/>
-          </a:effectRef>
-          <a:fontRef idx="minor">
-            <a:schemeClr val="lt1"/>
-          </a:fontRef>
-        </p:style>
-        <p:txBody>
-          <a:bodyPr rtlCol="0" anchor="ctr"/>
-          <a:lstStyle/>
-          <a:p/>
-        </p:txBody>
-      </p:sp>
-      <p:sp>
-        <p:nvSpPr>
-          <p:cNvPr id="25" name="TextBox 24"/>
-          <p:cNvSpPr txBox="1"/>
-          <p:nvPr/>
-        </p:nvSpPr>
-        <p:spPr>
-          <a:xfrm>
-            <a:off x="4526279" y="3410712"/>
-            <a:ext cx="2240280" cy="548640"/>
-          </a:xfrm>
-          <a:prstGeom prst="rect">
-            <a:avLst/>
-          </a:prstGeom>
-          <a:noFill/>
-        </p:spPr>
-        <p:txBody>
-          <a:bodyPr wrap="square" lIns="0" rIns="0" tIns="0" bIns="0" anchor="t">
-            <a:spAutoFit/>
-          </a:bodyPr>
-          <a:lstStyle/>
-          <a:p>
-            <a:pPr algn="l"/>
-            <a:r>
-              <a:rPr sz="1300" b="1" i="0">
-                <a:solidFill>
-                  <a:srgbClr val="003366"/>
-                </a:solidFill>
-                <a:latin typeface="Calibri"/>
-              </a:rPr>
-              <a:t>Segregated client-funds accounts</a:t>
-            </a:r>
-          </a:p>
-        </p:txBody>
-      </p:sp>
-      <p:sp>
-        <p:nvSpPr>
-          <p:cNvPr id="26" name="Rounded Rectangle 25"/>
-          <p:cNvSpPr/>
-          <p:nvPr/>
-        </p:nvSpPr>
-        <p:spPr>
-          <a:xfrm>
-            <a:off x="6903720" y="3429000"/>
-            <a:ext cx="777240" cy="256032"/>
-          </a:xfrm>
-          <a:prstGeom prst="roundRect">
-            <a:avLst>
-              <a:gd name="adj" fmla="val 50000"/>
-            </a:avLst>
-          </a:prstGeom>
-          <a:solidFill>
-            <a:srgbClr val="1F7A4D"/>
-          </a:solidFill>
-          <a:ln>
-            <a:noFill/>
-          </a:ln>
-          <a:effectLst/>
-        </p:spPr>
-        <p:style>
-          <a:lnRef idx="1">
-            <a:schemeClr val="accent1"/>
-          </a:lnRef>
-          <a:fillRef idx="3">
-            <a:schemeClr val="accent1"/>
-          </a:fillRef>
-          <a:effectRef idx="2">
-            <a:schemeClr val="accent1"/>
-          </a:effectRef>
-          <a:fontRef idx="minor">
-            <a:schemeClr val="lt1"/>
-          </a:fontRef>
-        </p:style>
-        <p:txBody>
-          <a:bodyPr rtlCol="0" anchor="ctr" lIns="0" rIns="0" tIns="0" bIns="0"/>
-          <a:lstStyle/>
-          <a:p>
-            <a:pPr algn="ctr"/>
-            <a:r>
-              <a:rPr sz="800" b="1">
-                <a:solidFill>
-                  <a:srgbClr val="FFFFFF"/>
-                </a:solidFill>
-                <a:latin typeface="Calibri"/>
-              </a:rPr>
-              <a:t>DONE</a:t>
-            </a:r>
-          </a:p>
-        </p:txBody>
-      </p:sp>
-      <p:sp>
-        <p:nvSpPr>
-          <p:cNvPr id="27" name="TextBox 26"/>
-          <p:cNvSpPr txBox="1"/>
-          <p:nvPr/>
-        </p:nvSpPr>
-        <p:spPr>
-          <a:xfrm>
-            <a:off x="4526279" y="4023359"/>
-            <a:ext cx="3108960" cy="228600"/>
-          </a:xfrm>
-          <a:prstGeom prst="rect">
-            <a:avLst/>
-          </a:prstGeom>
-          <a:noFill/>
-        </p:spPr>
-        <p:txBody>
-          <a:bodyPr wrap="square" lIns="0" rIns="0" tIns="0" bIns="0" anchor="t">
-            <a:spAutoFit/>
-          </a:bodyPr>
-          <a:lstStyle/>
-          <a:p>
-            <a:pPr algn="l"/>
-            <a:r>
-              <a:rPr sz="850" b="1" i="0" spc="80">
-                <a:solidFill>
-                  <a:srgbClr val="7A8A9B"/>
-                </a:solidFill>
-                <a:latin typeface="Calibri"/>
-              </a:rPr>
-              <a:t>FINANCE</a:t>
-            </a:r>
-          </a:p>
-        </p:txBody>
-      </p:sp>
-      <p:sp>
-        <p:nvSpPr>
-          <p:cNvPr id="28" name="TextBox 27"/>
-          <p:cNvSpPr txBox="1"/>
-          <p:nvPr/>
-        </p:nvSpPr>
-        <p:spPr>
-          <a:xfrm>
-            <a:off x="4526279" y="4224528"/>
-            <a:ext cx="3108960" cy="274320"/>
-          </a:xfrm>
-          <a:prstGeom prst="rect">
-            <a:avLst/>
-          </a:prstGeom>
-          <a:noFill/>
-        </p:spPr>
-        <p:txBody>
-          <a:bodyPr wrap="square" lIns="0" rIns="0" tIns="0" bIns="0" anchor="t">
-            <a:spAutoFit/>
-          </a:bodyPr>
-          <a:lstStyle/>
-          <a:p>
-            <a:pPr algn="l"/>
-            <a:r>
-              <a:rPr sz="1100" b="0" i="0">
-                <a:solidFill>
-                  <a:srgbClr val="1C2B3A"/>
-                </a:solidFill>
-                <a:latin typeface="Calibri"/>
-              </a:rPr>
-              <a:t>Done 24 Sept: one per organisation</a:t>
-            </a:r>
-          </a:p>
-        </p:txBody>
-      </p:sp>
-      <p:sp>
-        <p:nvSpPr>
-          <p:cNvPr id="29" name="Rounded Rectangle 28"/>
-          <p:cNvSpPr/>
-          <p:nvPr/>
-        </p:nvSpPr>
-        <p:spPr>
-          <a:xfrm>
-            <a:off x="8046719" y="3246120"/>
-            <a:ext cx="3566160" cy="1280160"/>
-          </a:xfrm>
-          <a:prstGeom prst="roundRect">
-            <a:avLst>
-              <a:gd name="adj" fmla="val 6000"/>
-            </a:avLst>
-          </a:prstGeom>
-          <a:solidFill>
-            <a:srgbClr val="FFFFFF"/>
-          </a:solidFill>
-          <a:ln w="9525">
-            <a:solidFill>
-              <a:srgbClr val="D8E0EA"/>
-            </a:solidFill>
-          </a:ln>
-          <a:effectLst/>
-        </p:spPr>
-        <p:style>
-          <a:lnRef idx="1">
-            <a:schemeClr val="accent1"/>
-          </a:lnRef>
-          <a:fillRef idx="3">
-            <a:schemeClr val="accent1"/>
-          </a:fillRef>
-          <a:effectRef idx="2">
-            <a:schemeClr val="accent1"/>
-          </a:effectRef>
-          <a:fontRef idx="minor">
-            <a:schemeClr val="lt1"/>
-          </a:fontRef>
-        </p:style>
-        <p:txBody>
-          <a:bodyPr rtlCol="0" anchor="ctr"/>
-          <a:lstStyle/>
-          <a:p/>
-        </p:txBody>
-      </p:sp>
-      <p:sp>
-        <p:nvSpPr>
-          <p:cNvPr id="30" name="TextBox 29"/>
-          <p:cNvSpPr txBox="1"/>
-          <p:nvPr/>
-        </p:nvSpPr>
-        <p:spPr>
-          <a:xfrm>
-            <a:off x="8275319" y="3410712"/>
-            <a:ext cx="2240280" cy="548640"/>
-          </a:xfrm>
-          <a:prstGeom prst="rect">
-            <a:avLst/>
-          </a:prstGeom>
-          <a:noFill/>
-        </p:spPr>
-        <p:txBody>
-          <a:bodyPr wrap="square" lIns="0" rIns="0" tIns="0" bIns="0" anchor="t">
-            <a:spAutoFit/>
-          </a:bodyPr>
-          <a:lstStyle/>
-          <a:p>
-            <a:pPr algn="l"/>
-            <a:r>
-              <a:rPr sz="1300" b="1" i="0">
-                <a:solidFill>
-                  <a:srgbClr val="003366"/>
-                </a:solidFill>
-                <a:latin typeface="Calibri"/>
-              </a:rPr>
-              <a:t>Gateway minute (decision 4)</a:t>
-            </a:r>
-          </a:p>
-        </p:txBody>
-      </p:sp>
-      <p:sp>
-        <p:nvSpPr>
-          <p:cNvPr id="31" name="Rounded Rectangle 30"/>
-          <p:cNvSpPr/>
-          <p:nvPr/>
-        </p:nvSpPr>
-        <p:spPr>
-          <a:xfrm>
-            <a:off x="10652759" y="3429000"/>
-            <a:ext cx="777240" cy="256032"/>
-          </a:xfrm>
-          <a:prstGeom prst="roundRect">
-            <a:avLst>
-              <a:gd name="adj" fmla="val 50000"/>
-            </a:avLst>
-          </a:prstGeom>
-          <a:solidFill>
-            <a:srgbClr val="B5680A"/>
-          </a:solidFill>
-          <a:ln>
-            <a:noFill/>
-          </a:ln>
-          <a:effectLst/>
-        </p:spPr>
-        <p:style>
-          <a:lnRef idx="1">
-            <a:schemeClr val="accent1"/>
-          </a:lnRef>
-          <a:fillRef idx="3">
-            <a:schemeClr val="accent1"/>
-          </a:fillRef>
-          <a:effectRef idx="2">
-            <a:schemeClr val="accent1"/>
-          </a:effectRef>
-          <a:fontRef idx="minor">
-            <a:schemeClr val="lt1"/>
-          </a:fontRef>
-        </p:style>
-        <p:txBody>
-          <a:bodyPr rtlCol="0" anchor="ctr" lIns="0" rIns="0" tIns="0" bIns="0"/>
-          <a:lstStyle/>
-          <a:p>
-            <a:pPr algn="ctr"/>
-            <a:r>
-              <a:rPr sz="800" b="1">
-                <a:solidFill>
-                  <a:srgbClr val="FFFFFF"/>
-                </a:solidFill>
-                <a:latin typeface="Calibri"/>
-              </a:rPr>
-              <a:t>PART</a:t>
-            </a:r>
-          </a:p>
-        </p:txBody>
-      </p:sp>
-      <p:sp>
-        <p:nvSpPr>
-          <p:cNvPr id="32" name="TextBox 31"/>
-          <p:cNvSpPr txBox="1"/>
-          <p:nvPr/>
-        </p:nvSpPr>
-        <p:spPr>
-          <a:xfrm>
-            <a:off x="8275319" y="4023359"/>
-            <a:ext cx="3108960" cy="228600"/>
-          </a:xfrm>
-          <a:prstGeom prst="rect">
-            <a:avLst/>
-          </a:prstGeom>
-          <a:noFill/>
-        </p:spPr>
-        <p:txBody>
-          <a:bodyPr wrap="square" lIns="0" rIns="0" tIns="0" bIns="0" anchor="t">
-            <a:spAutoFit/>
-          </a:bodyPr>
-          <a:lstStyle/>
-          <a:p>
-            <a:pPr algn="l"/>
-            <a:r>
-              <a:rPr sz="850" b="1" i="0" spc="80">
-                <a:solidFill>
-                  <a:srgbClr val="7A8A9B"/>
-                </a:solidFill>
-                <a:latin typeface="Calibri"/>
-              </a:rPr>
-              <a:t>BOARD</a:t>
-            </a:r>
-          </a:p>
-        </p:txBody>
-      </p:sp>
-      <p:sp>
-        <p:nvSpPr>
-          <p:cNvPr id="33" name="TextBox 32"/>
-          <p:cNvSpPr txBox="1"/>
-          <p:nvPr/>
-        </p:nvSpPr>
-        <p:spPr>
-          <a:xfrm>
-            <a:off x="8275319" y="4224528"/>
-            <a:ext cx="3108960" cy="274320"/>
-          </a:xfrm>
-          <a:prstGeom prst="rect">
-            <a:avLst/>
-          </a:prstGeom>
-          <a:noFill/>
-        </p:spPr>
-        <p:txBody>
-          <a:bodyPr wrap="square" lIns="0" rIns="0" tIns="0" bIns="0" anchor="t">
-            <a:spAutoFit/>
-          </a:bodyPr>
-          <a:lstStyle/>
-          <a:p>
-            <a:pPr algn="l"/>
-            <a:r>
-              <a:rPr sz="1100" b="0" i="0">
-                <a:solidFill>
-                  <a:srgbClr val="1C2B3A"/>
-                </a:solidFill>
-                <a:latin typeface="Calibri"/>
-              </a:rPr>
-              <a:t>Drafted; awaiting signature</a:t>
-            </a:r>
-          </a:p>
-        </p:txBody>
-      </p:sp>
-      <p:sp>
-        <p:nvSpPr>
-          <p:cNvPr id="34" name="Rounded Rectangle 33"/>
-          <p:cNvSpPr/>
-          <p:nvPr/>
-        </p:nvSpPr>
-        <p:spPr>
-          <a:xfrm>
-            <a:off x="548640" y="4709159"/>
-            <a:ext cx="3566160" cy="1280160"/>
-          </a:xfrm>
-          <a:prstGeom prst="roundRect">
-            <a:avLst>
-              <a:gd name="adj" fmla="val 6000"/>
-            </a:avLst>
-          </a:prstGeom>
-          <a:solidFill>
-            <a:srgbClr val="FFFFFF"/>
-          </a:solidFill>
-          <a:ln w="9525">
-            <a:solidFill>
-              <a:srgbClr val="D8E0EA"/>
-            </a:solidFill>
-          </a:ln>
-          <a:effectLst/>
-        </p:spPr>
-        <p:style>
-          <a:lnRef idx="1">
-            <a:schemeClr val="accent1"/>
-          </a:lnRef>
-          <a:fillRef idx="3">
-            <a:schemeClr val="accent1"/>
-          </a:fillRef>
-          <a:effectRef idx="2">
-            <a:schemeClr val="accent1"/>
-          </a:effectRef>
-          <a:fontRef idx="minor">
-            <a:schemeClr val="lt1"/>
-          </a:fontRef>
-        </p:style>
-        <p:txBody>
-          <a:bodyPr rtlCol="0" anchor="ctr"/>
-          <a:lstStyle/>
-          <a:p/>
-        </p:txBody>
-      </p:sp>
-      <p:sp>
-        <p:nvSpPr>
-          <p:cNvPr id="35" name="TextBox 34"/>
-          <p:cNvSpPr txBox="1"/>
-          <p:nvPr/>
-        </p:nvSpPr>
-        <p:spPr>
-          <a:xfrm>
-            <a:off x="777240" y="4873751"/>
-            <a:ext cx="2240280" cy="548640"/>
-          </a:xfrm>
-          <a:prstGeom prst="rect">
-            <a:avLst/>
-          </a:prstGeom>
-          <a:noFill/>
-        </p:spPr>
-        <p:txBody>
-          <a:bodyPr wrap="square" lIns="0" rIns="0" tIns="0" bIns="0" anchor="t">
-            <a:spAutoFit/>
-          </a:bodyPr>
-          <a:lstStyle/>
-          <a:p>
-            <a:pPr algn="l"/>
-            <a:r>
-              <a:rPr sz="1300" b="1" i="0">
-                <a:solidFill>
-                  <a:srgbClr val="003366"/>
-                </a:solidFill>
-                <a:latin typeface="Calibri"/>
-              </a:rPr>
-              <a:t>Special-category data decision</a:t>
-            </a:r>
-          </a:p>
-        </p:txBody>
-      </p:sp>
-      <p:sp>
-        <p:nvSpPr>
-          <p:cNvPr id="36" name="Rounded Rectangle 35"/>
-          <p:cNvSpPr/>
-          <p:nvPr/>
-        </p:nvSpPr>
-        <p:spPr>
-          <a:xfrm>
-            <a:off x="3154680" y="4892040"/>
-            <a:ext cx="777240" cy="256032"/>
-          </a:xfrm>
-          <a:prstGeom prst="roundRect">
-            <a:avLst>
-              <a:gd name="adj" fmla="val 50000"/>
-            </a:avLst>
-          </a:prstGeom>
-          <a:solidFill>
-            <a:srgbClr val="B23A2E"/>
-          </a:solidFill>
-          <a:ln>
-            <a:noFill/>
-          </a:ln>
-          <a:effectLst/>
-        </p:spPr>
-        <p:style>
-          <a:lnRef idx="1">
-            <a:schemeClr val="accent1"/>
-          </a:lnRef>
-          <a:fillRef idx="3">
-            <a:schemeClr val="accent1"/>
-          </a:fillRef>
-          <a:effectRef idx="2">
-            <a:schemeClr val="accent1"/>
-          </a:effectRef>
-          <a:fontRef idx="minor">
-            <a:schemeClr val="lt1"/>
-          </a:fontRef>
-        </p:style>
-        <p:txBody>
-          <a:bodyPr rtlCol="0" anchor="ctr" lIns="0" rIns="0" tIns="0" bIns="0"/>
-          <a:lstStyle/>
-          <a:p>
-            <a:pPr algn="ctr"/>
-            <a:r>
-              <a:rPr sz="800" b="1">
-                <a:solidFill>
-                  <a:srgbClr val="FFFFFF"/>
-                </a:solidFill>
-                <a:latin typeface="Calibri"/>
-              </a:rPr>
-              <a:t>OPEN</a:t>
-            </a:r>
-          </a:p>
-        </p:txBody>
-      </p:sp>
-      <p:sp>
-        <p:nvSpPr>
-          <p:cNvPr id="37" name="TextBox 36"/>
-          <p:cNvSpPr txBox="1"/>
-          <p:nvPr/>
-        </p:nvSpPr>
-        <p:spPr>
-          <a:xfrm>
-            <a:off x="777240" y="5486399"/>
-            <a:ext cx="3108960" cy="228600"/>
-          </a:xfrm>
-          <a:prstGeom prst="rect">
-            <a:avLst/>
-          </a:prstGeom>
-          <a:noFill/>
-        </p:spPr>
-        <p:txBody>
-          <a:bodyPr wrap="square" lIns="0" rIns="0" tIns="0" bIns="0" anchor="t">
-            <a:spAutoFit/>
-          </a:bodyPr>
-          <a:lstStyle/>
-          <a:p>
-            <a:pPr algn="l"/>
-            <a:r>
-              <a:rPr sz="850" b="1" i="0" spc="80">
-                <a:solidFill>
-                  <a:srgbClr val="7A8A9B"/>
-                </a:solidFill>
-                <a:latin typeface="Calibri"/>
-              </a:rPr>
-              <a:t>BOARD</a:t>
-            </a:r>
-          </a:p>
-        </p:txBody>
-      </p:sp>
-      <p:sp>
-        <p:nvSpPr>
-          <p:cNvPr id="38" name="TextBox 37"/>
-          <p:cNvSpPr txBox="1"/>
-          <p:nvPr/>
-        </p:nvSpPr>
-        <p:spPr>
-          <a:xfrm>
-            <a:off x="777240" y="5687568"/>
-            <a:ext cx="3108960" cy="274320"/>
-          </a:xfrm>
-          <a:prstGeom prst="rect">
-            <a:avLst/>
-          </a:prstGeom>
-          <a:noFill/>
-        </p:spPr>
-        <p:txBody>
-          <a:bodyPr wrap="square" lIns="0" rIns="0" tIns="0" bIns="0" anchor="t">
-            <a:spAutoFit/>
-          </a:bodyPr>
-          <a:lstStyle/>
-          <a:p>
-            <a:pPr algn="l"/>
-            <a:r>
-              <a:rPr sz="1100" b="0" i="0">
-                <a:solidFill>
-                  <a:srgbClr val="1C2B3A"/>
-                </a:solidFill>
-                <a:latin typeface="Calibri"/>
-              </a:rPr>
-              <a:t>Not yet decided</a:t>
-            </a:r>
-          </a:p>
-        </p:txBody>
-      </p:sp>
-      <p:sp>
-        <p:nvSpPr>
-          <p:cNvPr id="39" name="Rounded Rectangle 38"/>
-          <p:cNvSpPr/>
-          <p:nvPr/>
-        </p:nvSpPr>
-        <p:spPr>
-          <a:xfrm>
-            <a:off x="4297679" y="4709159"/>
-            <a:ext cx="3566160" cy="1280160"/>
-          </a:xfrm>
-          <a:prstGeom prst="roundRect">
-            <a:avLst>
-              <a:gd name="adj" fmla="val 6000"/>
-            </a:avLst>
-          </a:prstGeom>
-          <a:solidFill>
-            <a:srgbClr val="FFFFFF"/>
-          </a:solidFill>
-          <a:ln w="9525">
-            <a:solidFill>
-              <a:srgbClr val="D8E0EA"/>
-            </a:solidFill>
-          </a:ln>
-          <a:effectLst/>
-        </p:spPr>
-        <p:style>
-          <a:lnRef idx="1">
-            <a:schemeClr val="accent1"/>
-          </a:lnRef>
-          <a:fillRef idx="3">
-            <a:schemeClr val="accent1"/>
-          </a:fillRef>
-          <a:effectRef idx="2">
-            <a:schemeClr val="accent1"/>
-          </a:effectRef>
-          <a:fontRef idx="minor">
-            <a:schemeClr val="lt1"/>
-          </a:fontRef>
-        </p:style>
-        <p:txBody>
-          <a:bodyPr rtlCol="0" anchor="ctr"/>
-          <a:lstStyle/>
-          <a:p/>
-        </p:txBody>
-      </p:sp>
-      <p:sp>
-        <p:nvSpPr>
-          <p:cNvPr id="40" name="TextBox 39"/>
-          <p:cNvSpPr txBox="1"/>
-          <p:nvPr/>
-        </p:nvSpPr>
-        <p:spPr>
-          <a:xfrm>
-            <a:off x="4526279" y="4873751"/>
-            <a:ext cx="2240280" cy="548640"/>
-          </a:xfrm>
-          <a:prstGeom prst="rect">
-            <a:avLst/>
-          </a:prstGeom>
-          <a:noFill/>
-        </p:spPr>
-        <p:txBody>
-          <a:bodyPr wrap="square" lIns="0" rIns="0" tIns="0" bIns="0" anchor="t">
-            <a:spAutoFit/>
-          </a:bodyPr>
-          <a:lstStyle/>
-          <a:p>
-            <a:pPr algn="l"/>
-            <a:r>
-              <a:rPr sz="1300" b="1" i="0">
-                <a:solidFill>
-                  <a:srgbClr val="003366"/>
-                </a:solidFill>
-                <a:latin typeface="Calibri"/>
-              </a:rPr>
-              <a:t>External penetration test</a:t>
-            </a:r>
-          </a:p>
-        </p:txBody>
-      </p:sp>
-      <p:sp>
-        <p:nvSpPr>
-          <p:cNvPr id="41" name="Rounded Rectangle 40"/>
-          <p:cNvSpPr/>
-          <p:nvPr/>
-        </p:nvSpPr>
-        <p:spPr>
-          <a:xfrm>
-            <a:off x="6903720" y="4892040"/>
-            <a:ext cx="777240" cy="256032"/>
-          </a:xfrm>
-          <a:prstGeom prst="roundRect">
-            <a:avLst>
-              <a:gd name="adj" fmla="val 50000"/>
-            </a:avLst>
-          </a:prstGeom>
-          <a:solidFill>
-            <a:srgbClr val="1F7A4D"/>
-          </a:solidFill>
-          <a:ln>
-            <a:noFill/>
-          </a:ln>
-          <a:effectLst/>
-        </p:spPr>
-        <p:style>
-          <a:lnRef idx="1">
-            <a:schemeClr val="accent1"/>
-          </a:lnRef>
-          <a:fillRef idx="3">
-            <a:schemeClr val="accent1"/>
-          </a:fillRef>
-          <a:effectRef idx="2">
-            <a:schemeClr val="accent1"/>
-          </a:effectRef>
-          <a:fontRef idx="minor">
-            <a:schemeClr val="lt1"/>
-          </a:fontRef>
-        </p:style>
-        <p:txBody>
-          <a:bodyPr rtlCol="0" anchor="ctr" lIns="0" rIns="0" tIns="0" bIns="0"/>
-          <a:lstStyle/>
-          <a:p>
-            <a:pPr algn="ctr"/>
-            <a:r>
-              <a:rPr sz="800" b="1">
-                <a:solidFill>
-                  <a:srgbClr val="FFFFFF"/>
-                </a:solidFill>
-                <a:latin typeface="Calibri"/>
-              </a:rPr>
-              <a:t>DONE</a:t>
-            </a:r>
-          </a:p>
-        </p:txBody>
-      </p:sp>
-      <p:sp>
-        <p:nvSpPr>
-          <p:cNvPr id="42" name="TextBox 41"/>
-          <p:cNvSpPr txBox="1"/>
-          <p:nvPr/>
-        </p:nvSpPr>
-        <p:spPr>
-          <a:xfrm>
-            <a:off x="4526279" y="5486399"/>
-            <a:ext cx="3108960" cy="228600"/>
-          </a:xfrm>
-          <a:prstGeom prst="rect">
-            <a:avLst/>
-          </a:prstGeom>
-          <a:noFill/>
-        </p:spPr>
-        <p:txBody>
-          <a:bodyPr wrap="square" lIns="0" rIns="0" tIns="0" bIns="0" anchor="t">
-            <a:spAutoFit/>
-          </a:bodyPr>
-          <a:lstStyle/>
-          <a:p>
-            <a:pPr algn="l"/>
-            <a:r>
-              <a:rPr sz="850" b="1" i="0" spc="80">
-                <a:solidFill>
-                  <a:srgbClr val="7A8A9B"/>
-                </a:solidFill>
-                <a:latin typeface="Calibri"/>
-              </a:rPr>
-              <a:t>BOARD</a:t>
-            </a:r>
-          </a:p>
-        </p:txBody>
-      </p:sp>
-      <p:sp>
-        <p:nvSpPr>
-          <p:cNvPr id="43" name="TextBox 42"/>
-          <p:cNvSpPr txBox="1"/>
-          <p:nvPr/>
-        </p:nvSpPr>
-        <p:spPr>
-          <a:xfrm>
-            <a:off x="4526279" y="5687568"/>
-            <a:ext cx="3108960" cy="274320"/>
-          </a:xfrm>
-          <a:prstGeom prst="rect">
-            <a:avLst/>
-          </a:prstGeom>
-          <a:noFill/>
-        </p:spPr>
-        <p:txBody>
-          <a:bodyPr wrap="square" lIns="0" rIns="0" tIns="0" bIns="0" anchor="t">
-            <a:spAutoFit/>
-          </a:bodyPr>
-          <a:lstStyle/>
-          <a:p>
-            <a:pPr algn="l"/>
-            <a:r>
-              <a:rPr sz="1100" b="0" i="0">
-                <a:solidFill>
-                  <a:srgbClr val="1C2B3A"/>
-                </a:solidFill>
-                <a:latin typeface="Calibri"/>
-              </a:rPr>
-              <a:t>Done; report to be filed</a:t>
-            </a:r>
-          </a:p>
-        </p:txBody>
-      </p:sp>
-      <p:sp>
-        <p:nvSpPr>
-          <p:cNvPr id="44" name="Rounded Rectangle 43"/>
-          <p:cNvSpPr/>
-          <p:nvPr/>
-        </p:nvSpPr>
-        <p:spPr>
-          <a:xfrm>
-            <a:off x="8046719" y="4709159"/>
-            <a:ext cx="3566160" cy="1280160"/>
-          </a:xfrm>
-          <a:prstGeom prst="roundRect">
-            <a:avLst>
-              <a:gd name="adj" fmla="val 6000"/>
-            </a:avLst>
-          </a:prstGeom>
-          <a:solidFill>
-            <a:srgbClr val="FFFFFF"/>
-          </a:solidFill>
-          <a:ln w="9525">
-            <a:solidFill>
-              <a:srgbClr val="D8E0EA"/>
-            </a:solidFill>
-          </a:ln>
-          <a:effectLst/>
-        </p:spPr>
-        <p:style>
-          <a:lnRef idx="1">
-            <a:schemeClr val="accent1"/>
-          </a:lnRef>
-          <a:fillRef idx="3">
-            <a:schemeClr val="accent1"/>
-          </a:fillRef>
-          <a:effectRef idx="2">
-            <a:schemeClr val="accent1"/>
-          </a:effectRef>
-          <a:fontRef idx="minor">
-            <a:schemeClr val="lt1"/>
-          </a:fontRef>
-        </p:style>
-        <p:txBody>
-          <a:bodyPr rtlCol="0" anchor="ctr"/>
-          <a:lstStyle/>
-          <a:p/>
-        </p:txBody>
-      </p:sp>
-      <p:sp>
-        <p:nvSpPr>
-          <p:cNvPr id="45" name="TextBox 44"/>
-          <p:cNvSpPr txBox="1"/>
-          <p:nvPr/>
-        </p:nvSpPr>
-        <p:spPr>
-          <a:xfrm>
-            <a:off x="8275319" y="4873751"/>
-            <a:ext cx="2240280" cy="548640"/>
-          </a:xfrm>
-          <a:prstGeom prst="rect">
-            <a:avLst/>
-          </a:prstGeom>
-          <a:noFill/>
-        </p:spPr>
-        <p:txBody>
-          <a:bodyPr wrap="square" lIns="0" rIns="0" tIns="0" bIns="0" anchor="t">
-            <a:spAutoFit/>
-          </a:bodyPr>
-          <a:lstStyle/>
-          <a:p>
-            <a:pPr algn="l"/>
-            <a:r>
-              <a:rPr sz="1300" b="1" i="0">
-                <a:solidFill>
-                  <a:srgbClr val="003366"/>
-                </a:solidFill>
-                <a:latin typeface="Calibri"/>
-              </a:rPr>
-              <a:t>Go-live date and GO</a:t>
-            </a:r>
-          </a:p>
-        </p:txBody>
-      </p:sp>
-      <p:sp>
-        <p:nvSpPr>
-          <p:cNvPr id="46" name="Rounded Rectangle 45"/>
-          <p:cNvSpPr/>
-          <p:nvPr/>
-        </p:nvSpPr>
-        <p:spPr>
-          <a:xfrm>
-            <a:off x="10652759" y="4892040"/>
-            <a:ext cx="777240" cy="256032"/>
-          </a:xfrm>
-          <a:prstGeom prst="roundRect">
-            <a:avLst>
-              <a:gd name="adj" fmla="val 50000"/>
-            </a:avLst>
-          </a:prstGeom>
-          <a:solidFill>
-            <a:srgbClr val="1F7A4D"/>
-          </a:solidFill>
-          <a:ln>
-            <a:noFill/>
-          </a:ln>
-          <a:effectLst/>
-        </p:spPr>
-        <p:style>
-          <a:lnRef idx="1">
-            <a:schemeClr val="accent1"/>
-          </a:lnRef>
-          <a:fillRef idx="3">
-            <a:schemeClr val="accent1"/>
-          </a:fillRef>
-          <a:effectRef idx="2">
-            <a:schemeClr val="accent1"/>
-          </a:effectRef>
-          <a:fontRef idx="minor">
-            <a:schemeClr val="lt1"/>
-          </a:fontRef>
-        </p:style>
-        <p:txBody>
-          <a:bodyPr rtlCol="0" anchor="ctr" lIns="0" rIns="0" tIns="0" bIns="0"/>
-          <a:lstStyle/>
-          <a:p>
-            <a:pPr algn="ctr"/>
-            <a:r>
-              <a:rPr sz="800" b="1">
-                <a:solidFill>
-                  <a:srgbClr val="FFFFFF"/>
-                </a:solidFill>
-                <a:latin typeface="Calibri"/>
-              </a:rPr>
-              <a:t>DONE</a:t>
-            </a:r>
-          </a:p>
-        </p:txBody>
-      </p:sp>
-      <p:sp>
-        <p:nvSpPr>
-          <p:cNvPr id="47" name="TextBox 46"/>
-          <p:cNvSpPr txBox="1"/>
-          <p:nvPr/>
-        </p:nvSpPr>
-        <p:spPr>
-          <a:xfrm>
-            <a:off x="8275319" y="5486399"/>
-            <a:ext cx="3108960" cy="228600"/>
-          </a:xfrm>
-          <a:prstGeom prst="rect">
-            <a:avLst/>
-          </a:prstGeom>
-          <a:noFill/>
-        </p:spPr>
-        <p:txBody>
-          <a:bodyPr wrap="square" lIns="0" rIns="0" tIns="0" bIns="0" anchor="t">
-            <a:spAutoFit/>
-          </a:bodyPr>
-          <a:lstStyle/>
-          <a:p>
-            <a:pPr algn="l"/>
-            <a:r>
-              <a:rPr sz="850" b="1" i="0" spc="80">
-                <a:solidFill>
-                  <a:srgbClr val="7A8A9B"/>
-                </a:solidFill>
-                <a:latin typeface="Calibri"/>
-              </a:rPr>
-              <a:t>BOARD</a:t>
-            </a:r>
-          </a:p>
-        </p:txBody>
-      </p:sp>
-      <p:sp>
-        <p:nvSpPr>
-          <p:cNvPr id="48" name="TextBox 47"/>
-          <p:cNvSpPr txBox="1"/>
-          <p:nvPr/>
-        </p:nvSpPr>
-        <p:spPr>
-          <a:xfrm>
-            <a:off x="8275319" y="5687568"/>
-            <a:ext cx="3108960" cy="274320"/>
-          </a:xfrm>
-          <a:prstGeom prst="rect">
-            <a:avLst/>
-          </a:prstGeom>
-          <a:noFill/>
-        </p:spPr>
-        <p:txBody>
-          <a:bodyPr wrap="square" lIns="0" rIns="0" tIns="0" bIns="0" anchor="t">
-            <a:spAutoFit/>
-          </a:bodyPr>
-          <a:lstStyle/>
-          <a:p>
-            <a:pPr algn="l"/>
-            <a:r>
-              <a:rPr sz="1100" b="0" i="0">
-                <a:solidFill>
-                  <a:srgbClr val="1C2B3A"/>
-                </a:solidFill>
-                <a:latin typeface="Calibri"/>
-              </a:rPr>
-              <a:t>GO given 28 Sept</a:t>
-            </a:r>
-          </a:p>
-        </p:txBody>
-      </p:sp>
-      <p:sp>
-        <p:nvSpPr>
-          <p:cNvPr id="49" name="TextBox 48"/>
+              <a:t>point-in-time database recovery, about $100 a month per project. It was declined on cost at go-live, with backups after every loading session instead.</a:t>
+            </a:r>
+          </a:p>
+        </p:txBody>
+      </p:sp>
+      <p:sp>
+        <p:nvSpPr>
+          <p:cNvPr id="14" name="TextBox 13"/>
           <p:cNvSpPr txBox="1"/>
           <p:nvPr/>
         </p:nvSpPr>

</xml_diff>

<commit_message>
Cutover deck: corrected Stage 2 figures and today's status
Spending total corrected to the sum of its five lines, ₦539,158 (the memo
printed ₦541,800), so the overspend is ₦6,158 and the total owed
₦662,517.38. Contingency already spent on subscriptions: ₦192,356.
Paystack verified 2 Oct, Flutterwave 5 Oct, both live keys connected on
the OEA portal, first live payment not yet made. WhatsApp still off.
Monitoring is a discounted annual plan; AI is one ₦170,000 plan for the
first year. Legal has not yet returned the documents.

Co-Authored-By: Claude Opus 5.5 <noreply@anthropic.com>
</commit_message>
<xml_diff>
--- a/docs/OE_Group_Production_Cutover.pptx
+++ b/docs/OE_Group_Production_Cutover.pptx
@@ -792,7 +792,7 @@
           <a:lstStyle/>
           <a:p>
             <a:r>
-              <a:t>Memo section 4, figures exactly as stated. CHECK BEFORE PRESENTING: two rows do not follow month x 12. AI shows ₦170,000 a month and ₦170,000 a year; Monitoring shows ₦48,450 a month (x12 = ₦581,400) and ₦588,000 a year. ₦422,083.50 a month x 12 would be ₦5,065,002 a year, against the ₦3,201,602 stated. Replaces the 3 Sept table (₦516,375 a month).</a:t>
+              <a:t>Memo section 4, figures as stated. Two rows are annual plans rather than month x 12 (project lead, 7 Oct): AI is one ₦170,000 plan for the first year, with a top-up requested if it runs out; Monitoring is an annual subscription at a discount. So the yearly column (₦3,201,602) is what the plans cost; the monthly total is the memo's figure and is not x12 of the year. Replaces the 3 Sept table (₦516,375 a month).</a:t>
             </a:r>
           </a:p>
         </p:txBody>
@@ -862,7 +862,7 @@
           <a:lstStyle/>
           <a:p>
             <a:r>
-              <a:t>Tracker: 3.5/5.5a and 6.6 (keys and first real payment); decision 59 (Executive role); 1.1 processor agreements (none signed as of 28 Sept); 1.2 privacy notice (published 24 Sept, legal review owed); 1.5 NDPC registration. Special-category data (1.6) is also still undecided.</a:t>
+              <a:t>Live keys connected on the OEA portal; first live payment not yet made (project lead, 7 Oct; tracker 6.6). WhatsApp off since 1 Oct. Legal has not yet responded with the documentation (processor agreements, privacy notice review). decision 59 (Executive role); 1.1 processor agreements (none signed as of 28 Sept); 1.2 privacy notice (published 24 Sept, legal review owed); 1.5 NDPC registration. Special-category data (1.6) is also still undecided.</a:t>
             </a:r>
           </a:p>
         </p:txBody>
@@ -1072,7 +1072,7 @@
           <a:lstStyle/>
           <a:p>
             <a:r>
-              <a:t>Tracker dates: production deployed 24 Sept (5.2); self-assessment and load tests 26-27 Sept (6.1); board GO 28 Sept (6.4); Executive role and two-step sign-in merged 3 Oct. The date of the gateway approvals is per the project lead's report; 'Next' is tracker item 6.6, not yet done.</a:t>
+              <a:t>Tracker dates: production deployed 24 Sept (5.2); self-assessment and load tests 26-27 Sept (6.1); board GO 28 Sept (6.4); Executive role and two-step sign-in merged 3 Oct. Gateway approvals per the project lead: Paystack verified 2 Oct, Flutterwave 5 Oct; both live keys are connected on the OEA portal. 'Next' is tracker item 6.6, not yet done.</a:t>
             </a:r>
           </a:p>
         </p:txBody>
@@ -1422,7 +1422,7 @@
           <a:lstStyle/>
           <a:p>
             <a:r>
-              <a:t>Memo section 2 expenditure, as stated: new blank database 64,358; deployment manager 28,000; penetration and load test 247,000; 360dialog WABA 156,800; AI fallback (Google API) 43,000; total stated 541,800; balance -8,800. CHECK BEFORE PRESENTING: the five lines add to ₦539,158, not ₦541,800 (a ₦2,642 difference). Section 3: the WABA subscription expired 1 Oct and was cancelled; confirm whether WhatsApp is back on before presenting.</a:t>
+              <a:t>Memo section 2 expenditure, as stated: new blank database 64,358; deployment manager 28,000; penetration and load test 247,000; 360dialog WABA 156,800; AI fallback (Google API) 43,000. The memo printed a total of ₦541,800 and a balance of -₦8,800; the five lines add to ₦539,158, so the corrected total is ₦539,158 and the overspend ₦6,158 (corrected 7 Oct). WhatsApp is still off as of 7 Oct (project lead).</a:t>
             </a:r>
           </a:p>
         </p:txBody>
@@ -1492,7 +1492,7 @@
           <a:lstStyle/>
           <a:p>
             <a:r>
-              <a:t>Memo section 2 'Still owed': staff training 250,000; contingency reserve (15%) 406,359.38; total owed 665,159.38 (= 656,359.38 + the 8,800 overspend). Section 3: ₦193,158 of the contingency already spent on platform subscriptions. CHECK: the two starred subscription lines (database 64,358 + WABA 156,800) add to ₦221,158, not ₦193,158.</a:t>
+              <a:t>Memo section 2 'Still owed': staff training 250,000; contingency reserve (15%) 406,359.38; total owed 665,159.38 as printed; corrected here to ₦662,517.38 = 250,000 + 406,359.38 + the corrected ₦6,158 overspend. Contingency already spent on subscriptions: ₦192,356 (corrected by the project lead, 7 Oct; the memo printed ₦193,158).</a:t>
             </a:r>
           </a:p>
         </p:txBody>
@@ -4926,7 +4926,7 @@
                 </a:solidFill>
                 <a:latin typeface="Calibri"/>
               </a:rPr>
-              <a:t>Monthly subscriptions after go-live, from the 6 October memo.</a:t>
+              <a:t>About ₦3.2 million a year in subscription plans, from the 6 October memo.</a:t>
             </a:r>
           </a:p>
         </p:txBody>
@@ -6013,7 +6013,7 @@
                 </a:solidFill>
                 <a:latin typeface="Calibri"/>
               </a:rPr>
-              <a:t>Claude, with Gemini backup</a:t>
+              <a:t>One plan for the first year; top-up if it runs out</a:t>
             </a:r>
           </a:p>
         </p:txBody>
@@ -6276,7 +6276,7 @@
                 </a:solidFill>
                 <a:latin typeface="Calibri"/>
               </a:rPr>
-              <a:t>Sentry, Better Uptime (optional)</a:t>
+              <a:t>Annual plan, at a discount</a:t>
             </a:r>
           </a:p>
         </p:txBody>
@@ -7453,7 +7453,7 @@
                 </a:solidFill>
                 <a:latin typeface="Calibri"/>
               </a:rPr>
-              <a:t>Connect live payment keys</a:t>
+              <a:t>Make the first live payment</a:t>
             </a:r>
           </a:p>
         </p:txBody>
@@ -7488,7 +7488,7 @@
                 </a:solidFill>
                 <a:latin typeface="Calibri"/>
               </a:rPr>
-              <a:t>Then one real payment, checked by hand</a:t>
+              <a:t>Keys are connected; check it by hand</a:t>
             </a:r>
           </a:p>
         </p:txBody>
@@ -8145,7 +8145,7 @@
       </p:sp>
       <p:pic>
         <p:nvPicPr>
-          <p:cNvPr id="24" name="Picture 23" descr="ClipboardCheck.png"/>
+          <p:cNvPr id="24" name="Picture 23" descr="MessageCircle.png"/>
           <p:cNvPicPr>
             <a:picLocks noChangeAspect="1"/>
           </p:cNvPicPr>
@@ -8197,7 +8197,7 @@
                 </a:solidFill>
                 <a:latin typeface="Calibri"/>
               </a:rPr>
-              <a:t>Sign the data agreements</a:t>
+              <a:t>Switch WhatsApp back on</a:t>
             </a:r>
           </a:p>
         </p:txBody>
@@ -8232,7 +8232,7 @@
                 </a:solidFill>
                 <a:latin typeface="Calibri"/>
               </a:rPr>
-              <a:t>With each outside service provider</a:t>
+              <a:t>Off since 1 October; needs its subscription</a:t>
             </a:r>
           </a:p>
         </p:txBody>
@@ -8287,7 +8287,7 @@
                 </a:solidFill>
                 <a:latin typeface="Calibri"/>
               </a:rPr>
-              <a:t>OPEN</a:t>
+              <a:t>OFF</a:t>
             </a:r>
           </a:p>
         </p:txBody>
@@ -8393,7 +8393,7 @@
       </p:sp>
       <p:pic>
         <p:nvPicPr>
-          <p:cNvPr id="30" name="Picture 29" descr="ShieldCheck.png"/>
+          <p:cNvPr id="30" name="Picture 29" descr="ClipboardCheck.png"/>
           <p:cNvPicPr>
             <a:picLocks noChangeAspect="1"/>
           </p:cNvPicPr>
@@ -8445,7 +8445,7 @@
                 </a:solidFill>
                 <a:latin typeface="Calibri"/>
               </a:rPr>
-              <a:t>Legal review of the privacy notice</a:t>
+              <a:t>Legal documents</a:t>
             </a:r>
           </a:p>
         </p:txBody>
@@ -8480,7 +8480,7 @@
                 </a:solidFill>
                 <a:latin typeface="Calibri"/>
               </a:rPr>
-              <a:t>The notice is published; review owed</a:t>
+              <a:t>Legal has not yet sent them back</a:t>
             </a:r>
           </a:p>
         </p:txBody>
@@ -8535,7 +8535,7 @@
                 </a:solidFill>
                 <a:latin typeface="Calibri"/>
               </a:rPr>
-              <a:t>OPEN</a:t>
+              <a:t>WAITING</a:t>
             </a:r>
           </a:p>
         </p:txBody>
@@ -9132,7 +9132,7 @@
                 </a:solidFill>
                 <a:latin typeface="Calibri"/>
               </a:rPr>
-              <a:t>Approve the monthly subscriptions</a:t>
+              <a:t>Approve the subscription plans</a:t>
             </a:r>
           </a:p>
         </p:txBody>
@@ -9167,7 +9167,7 @@
                 </a:solidFill>
                 <a:latin typeface="Calibri"/>
               </a:rPr>
-              <a:t>About ₦422,000 a month, so no service is cut off. WhatsApp has already lapsed once.</a:t>
+              <a:t>About ₦3.2 million a year, so no service is cut off. WhatsApp is off right now.</a:t>
             </a:r>
           </a:p>
         </p:txBody>
@@ -10336,7 +10336,7 @@
                 </a:solidFill>
                 <a:latin typeface="Cambria"/>
               </a:rPr>
-              <a:t>Payments approved</a:t>
+              <a:t>Payments ready</a:t>
             </a:r>
           </a:p>
         </p:txBody>
@@ -10371,7 +10371,7 @@
                 </a:solidFill>
                 <a:latin typeface="Calibri"/>
               </a:rPr>
-              <a:t>Paystack and Flutterwave have both approved OEA's business verification.</a:t>
+              <a:t>Paystack and Flutterwave approved OEA, and both are now connected to OEA's portal.</a:t>
             </a:r>
           </a:p>
         </p:txBody>
@@ -11947,7 +11947,7 @@
                 </a:solidFill>
                 <a:latin typeface="Calibri"/>
               </a:rPr>
-              <a:t>Early Oct</a:t>
+              <a:t>2 &amp; 5 Oct</a:t>
             </a:r>
           </a:p>
         </p:txBody>
@@ -12063,7 +12063,7 @@
                 </a:solidFill>
                 <a:latin typeface="Calibri"/>
               </a:rPr>
-              <a:t>Paystack and Flutterwave approved OEA</a:t>
+              <a:t>Paystack on 2 Oct, Flutterwave on 5 Oct</a:t>
             </a:r>
           </a:p>
         </p:txBody>
@@ -12898,7 +12898,7 @@
                 </a:solidFill>
                 <a:latin typeface="Calibri"/>
               </a:rPr>
-              <a:t>Can send automatic payouts to vendors and landlords</a:t>
+              <a:t>Approved 2 October. Sends automatic payouts to vendors and landlords</a:t>
             </a:r>
           </a:p>
         </p:txBody>
@@ -13146,7 +13146,7 @@
                 </a:solidFill>
                 <a:latin typeface="Calibri"/>
               </a:rPr>
-              <a:t>Collects tenant payments, in Naira and foreign currency</a:t>
+              <a:t>Approved 5 October. Collects tenant payments, Naira and foreign currency</a:t>
             </a:r>
           </a:p>
         </p:txBody>
@@ -13201,7 +13201,7 @@
             <a:avLst/>
           </a:prstGeom>
           <a:solidFill>
-            <a:srgbClr val="0B2545"/>
+            <a:srgbClr val="16723F"/>
           </a:solidFill>
           <a:ln>
             <a:noFill/>
@@ -13234,7 +13234,7 @@
                 </a:solidFill>
                 <a:latin typeface="Cambria"/>
               </a:rPr>
-              <a:t>1</a:t>
+              <a:t>✓</a:t>
             </a:r>
           </a:p>
         </p:txBody>
@@ -13269,7 +13269,7 @@
                 </a:solidFill>
                 <a:latin typeface="Calibri"/>
               </a:rPr>
-              <a:t>Connect the live keys</a:t>
+              <a:t>Live keys connected</a:t>
             </a:r>
           </a:p>
         </p:txBody>
@@ -13304,7 +13304,7 @@
                 </a:solidFill>
                 <a:latin typeface="Calibri"/>
               </a:rPr>
-              <a:t>An administrator adds OEA's live keys for both providers in the system's banking settings.</a:t>
+              <a:t>Both providers' live keys are now plugged into OEA's portal. Done.</a:t>
             </a:r>
           </a:p>
         </p:txBody>
@@ -13631,7 +13631,7 @@
                 </a:solidFill>
                 <a:latin typeface="Calibri"/>
               </a:rPr>
-              <a:t>Until the keys are connected, </a:t>
+              <a:t>Until the first live payment is checked, </a:t>
             </a:r>
             <a:r>
               <a:rPr sz="1600" b="0" i="0">
@@ -17244,7 +17244,7 @@
                 </a:solidFill>
                 <a:latin typeface="Cambria"/>
               </a:rPr>
-              <a:t>₦541,800</a:t>
+              <a:t>₦539,158</a:t>
             </a:r>
           </a:p>
         </p:txBody>
@@ -17279,7 +17279,7 @@
                 </a:solidFill>
                 <a:latin typeface="Calibri"/>
               </a:rPr>
-              <a:t>₦8,800 more than released. The extra comes from the contingency reserve.</a:t>
+              <a:t>₦6,158 more than released. The extra comes from the contingency reserve.</a:t>
             </a:r>
           </a:p>
         </p:txBody>
@@ -17437,7 +17437,7 @@
                 </a:solidFill>
                 <a:latin typeface="Calibri"/>
               </a:rPr>
-              <a:t>WhatsApp lapsed</a:t>
+              <a:t>WhatsApp is off</a:t>
             </a:r>
           </a:p>
         </p:txBody>
@@ -17472,7 +17472,7 @@
                 </a:solidFill>
                 <a:latin typeface="Calibri"/>
               </a:rPr>
-              <a:t>The WhatsApp subscription expired on 1 October and was cancelled. It could not be paid out of pocket.</a:t>
+              <a:t>The WhatsApp subscription expired on 1 October and was cancelled. It is still off today.</a:t>
             </a:r>
           </a:p>
         </p:txBody>
@@ -18059,7 +18059,7 @@
                 </a:solidFill>
                 <a:latin typeface="Calibri"/>
               </a:rPr>
-              <a:t>₦193,158 of it has already gone on keeping subscriptions running, so work did not stall.</a:t>
+              <a:t>₦192,356 of it has already gone on keeping subscriptions running, so work did not stall.</a:t>
             </a:r>
           </a:p>
         </p:txBody>
@@ -18173,7 +18173,7 @@
                 </a:solidFill>
                 <a:latin typeface="Cambria"/>
               </a:rPr>
-              <a:t>₦665,159.38</a:t>
+              <a:t>₦662,517.38</a:t>
             </a:r>
           </a:p>
         </p:txBody>
@@ -18208,7 +18208,7 @@
                 </a:solidFill>
                 <a:latin typeface="Calibri"/>
               </a:rPr>
-              <a:t>Includes the ₦8,800 overspend. The contingency absorbs it, so the balance to release stays ₦533,359.38.</a:t>
+              <a:t>Includes the ₦6,158 overspend. The contingency absorbs it, so the balance to release stays ₦533,359.38.</a:t>
             </a:r>
           </a:p>
         </p:txBody>

</xml_diff>

<commit_message>
Cutover deck: Naira on Paystack, foreign currency on Flutterwave
Slide 12's payments ask now notes that payments run as the board first
decided (locked decision 4), and slide 4 says which provider does what:
Paystack takes Naira and pays out, Flutterwave takes foreign currency.

Co-Authored-By: Claude Opus 5.5 <noreply@anthropic.com>
</commit_message>
<xml_diff>
--- a/docs/OE_Group_Production_Cutover.pptx
+++ b/docs/OE_Group_Production_Cutover.pptx
@@ -932,7 +932,7 @@
           <a:lstStyle/>
           <a:p>
             <a:r>
-              <a:t>1-2 are the memo's recommendation (section 5). 3 replaces the 23 Sept draft minute (Flutterwave instead of Paystack): with both approved, the minute should record both, as the system already uses them. 4 per the project lead's update.</a:t>
+              <a:t>1-2 are the memo's recommendation (section 5). 3: on 7 Oct Naira collections moved back to Paystack, with Flutterwave for foreign currency. That is locked decision 4 as written, so the 23 Sept draft minute (Flutterwave for Naira) is superseded and should not be signed. 4 per the project lead's update.</a:t>
             </a:r>
           </a:p>
         </p:txBody>
@@ -1142,7 +1142,7 @@
           <a:lstStyle/>
           <a:p>
             <a:r>
-              <a:t>Both approvals are per the project lead's update of 7 Oct. How the system uses them, as built (decision 4 amendment, PR #53): Flutterwave is preferred for collecting Naira and foreign-currency payments; payouts use Paystack only. With both keys connected, collections go through Flutterwave and automatic payouts through Paystack. The board minute drafted on 23 Sept (Flutterwave replacing Paystack) should now record both. Connecting keys is tracker 3.5 and 5.5a; the first real payment is 6.6.</a:t>
+              <a:t>Paystack verified OEA on 2 Oct and Flutterwave on 5 Oct; both live keys are on the OEA portal. From 7 Oct the system routes Naira collections and all payouts through Paystack and every foreign currency through Flutterwave, which is locked decision 4 as originally written. Flutterwave takes Naira only for an org with no Paystack account. The first live payment is tracker 6.6.</a:t>
             </a:r>
           </a:p>
         </p:txBody>
@@ -9255,7 +9255,7 @@
                 </a:solidFill>
                 <a:latin typeface="Calibri"/>
               </a:rPr>
-              <a:t>Agree how the two payment providers are used</a:t>
+              <a:t>Note: payments run as the board first decided</a:t>
             </a:r>
           </a:p>
         </p:txBody>
@@ -9290,7 +9290,7 @@
                 </a:solidFill>
                 <a:latin typeface="Calibri"/>
               </a:rPr>
-              <a:t>Flutterwave to collect payments, Paystack to pay vendors and landlords.</a:t>
+              <a:t>Paystack for Naira, in and out. Flutterwave for foreign currency. No change to the rules is needed.</a:t>
             </a:r>
           </a:p>
         </p:txBody>
@@ -12898,7 +12898,7 @@
                 </a:solidFill>
                 <a:latin typeface="Calibri"/>
               </a:rPr>
-              <a:t>Approved 2 October. Sends automatic payouts to vendors and landlords</a:t>
+              <a:t>Approved 2 October. Takes Naira payments, and pays vendors and landlords</a:t>
             </a:r>
           </a:p>
         </p:txBody>
@@ -13146,7 +13146,7 @@
                 </a:solidFill>
                 <a:latin typeface="Calibri"/>
               </a:rPr>
-              <a:t>Approved 5 October. Collects tenant payments, Naira and foreign currency</a:t>
+              <a:t>Approved 5 October. Takes payments in foreign currency</a:t>
             </a:r>
           </a:p>
         </p:txBody>

</xml_diff>